<commit_message>
latest changes on 12/sept
</commit_message>
<xml_diff>
--- a/docs/presentations/Custos_Phase2_Review1.pptx
+++ b/docs/presentations/Custos_Phase2_Review1.pptx
@@ -23,7 +23,13 @@
     <p:sldId id="268" r:id="rId9"/>
     <p:sldId id="269" r:id="rId22"/>
     <p:sldId id="270" r:id="rId23"/>
-    <p:sldId id="271" r:id="rId10"/>
+    <p:sldId id="271" r:id="rId27"/>
+    <p:sldId id="272" r:id="rId28"/>
+    <p:sldId id="273" r:id="rId29"/>
+    <p:sldId id="274" r:id="rId24"/>
+    <p:sldId id="275" r:id="rId25"/>
+    <p:sldId id="276" r:id="rId26"/>
+    <p:sldId id="277" r:id="rId10"/>
   </p:sldIdLst>
   <p:sldSz cx="12192000" cy="6858000"/>
   <p:notesSz cx="6858000" cy="9144000"/>
@@ -4111,7 +4117,7 @@
           <a:p>
             <a:fld id="{3824AD60-7A91-4584-9CFF-40792E6A86E8}" type="datetime3">
               <a:rPr lang="en-US" smtClean="0"/>
-              <a:t>4 September 2026</a:t>
+              <a:t>12 September 2026</a:t>
             </a:fld>
             <a:endParaRPr lang="en-US" dirty="0"/>
           </a:p>
@@ -4355,7 +4361,7 @@
           <a:p>
             <a:fld id="{64C96E34-94C0-49E4-A53B-4A44141FD3C8}" type="datetime3">
               <a:rPr lang="en-US" smtClean="0"/>
-              <a:t>4 September 2026</a:t>
+              <a:t>12 September 2026</a:t>
             </a:fld>
             <a:endParaRPr lang="en-US" dirty="0"/>
           </a:p>
@@ -4623,7 +4629,7 @@
           <a:p>
             <a:fld id="{64C96E34-94C0-49E4-A53B-4A44141FD3C8}" type="datetime3">
               <a:rPr lang="en-US" smtClean="0"/>
-              <a:t>4 September 2026</a:t>
+              <a:t>12 September 2026</a:t>
             </a:fld>
             <a:endParaRPr lang="en-US" dirty="0"/>
           </a:p>
@@ -4891,7 +4897,7 @@
           <a:p>
             <a:fld id="{64C96E34-94C0-49E4-A53B-4A44141FD3C8}" type="datetime3">
               <a:rPr lang="en-US" smtClean="0"/>
-              <a:t>4 September 2026</a:t>
+              <a:t>12 September 2026</a:t>
             </a:fld>
             <a:endParaRPr lang="en-US" dirty="0"/>
           </a:p>
@@ -5159,7 +5165,7 @@
           <a:p>
             <a:fld id="{64C96E34-94C0-49E4-A53B-4A44141FD3C8}" type="datetime3">
               <a:rPr lang="en-US" smtClean="0"/>
-              <a:t>4 September 2026</a:t>
+              <a:t>12 September 2026</a:t>
             </a:fld>
             <a:endParaRPr lang="en-US" dirty="0"/>
           </a:p>
@@ -6111,7 +6117,7 @@
           <a:p>
             <a:fld id="{64C96E34-94C0-49E4-A53B-4A44141FD3C8}" type="datetime3">
               <a:rPr lang="en-US" smtClean="0"/>
-              <a:t>4 September 2026</a:t>
+              <a:t>12 September 2026</a:t>
             </a:fld>
             <a:endParaRPr lang="en-US" dirty="0"/>
           </a:p>
@@ -6379,7 +6385,7 @@
           <a:p>
             <a:fld id="{64C96E34-94C0-49E4-A53B-4A44141FD3C8}" type="datetime3">
               <a:rPr lang="en-US" smtClean="0"/>
-              <a:t>4 September 2026</a:t>
+              <a:t>12 September 2026</a:t>
             </a:fld>
             <a:endParaRPr lang="en-US" dirty="0"/>
           </a:p>
@@ -6538,7 +6544,7 @@
                 <a:ea typeface="Calibri" panose="020F0502020204030204" pitchFamily="34" charset="0"/>
                 <a:cs typeface="Calibri" panose="020F0502020204030204" pitchFamily="34" charset="0"/>
               </a:rPr>
-              <a:t>Contributions and Conclusion</a:t>
+              <a:t>Data and Validation</a:t>
             </a:r>
           </a:p>
         </p:txBody>
@@ -6578,96 +6584,28 @@
               <a:buNone/>
             </a:pPr>
             <a:r>
-              <a:rPr lang="en-US" sz="1400" b="1" i="0" dirty="0">
+              <a:rPr lang="en-US" sz="1400" b="0" i="0" dirty="0">
                 <a:latin typeface="Calibri" panose="020F0502020204030204" pitchFamily="34" charset="0"/>
                 <a:ea typeface="Calibri" panose="020F0502020204030204" pitchFamily="34" charset="0"/>
                 <a:cs typeface="Calibri" panose="020F0502020204030204" pitchFamily="34" charset="0"/>
               </a:rPr>
-              <a:t>268 tests passing · measured gateway p99 of 0.5 ms against a 50 ms budget · audit chain verified and demonstrated under an actual tampering attempt.</a:t>
+              <a:t>Custos contains no trained model, no fitted parameters, no weights. It is a measuring instrument — so it is validated the way instruments are, by calibration against known inputs, not by accuracy on held-out data.</a:t>
             </a:r>
           </a:p>
           <a:p>
             <a:pPr marL="0" indent="0" algn="l">
               <a:spcBef>
-                <a:spcPts val="350"/>
+                <a:spcPts val="260"/>
               </a:spcBef>
               <a:buNone/>
             </a:pPr>
             <a:r>
-              <a:rPr lang="en-US" sz="1600" b="1" i="0" dirty="0">
+              <a:rPr lang="en-US" sz="1300" b="0" i="0" dirty="0">
                 <a:latin typeface="Calibri" panose="020F0502020204030204" pitchFamily="34" charset="0"/>
                 <a:ea typeface="Calibri" panose="020F0502020204030204" pitchFamily="34" charset="0"/>
                 <a:cs typeface="Calibri" panose="020F0502020204030204" pitchFamily="34" charset="0"/>
               </a:rPr>
-              <a:t>Next, for Review-2</a:t>
-            </a:r>
-          </a:p>
-          <a:p>
-            <a:pPr marL="285750" indent="-285750" algn="l">
-              <a:spcBef>
-                <a:spcPts val="400"/>
-              </a:spcBef>
-              <a:buFont typeface="Arial" panose="020B0604020202020204" pitchFamily="34" charset="0"/>
-              <a:buChar char="•"/>
-            </a:pPr>
-            <a:r>
-              <a:rPr lang="en-US" sz="1350" b="0" i="0" dirty="0">
-                <a:latin typeface="Calibri" panose="020F0502020204030204" pitchFamily="34" charset="0"/>
-                <a:ea typeface="Calibri" panose="020F0502020204030204" pitchFamily="34" charset="0"/>
-                <a:cs typeface="Calibri" panose="020F0502020204030204" pitchFamily="34" charset="0"/>
-              </a:rPr>
-              <a:t>Validate against real drift using the Lending Club dataset, replacing the controlled synthetic scenarios.</a:t>
-            </a:r>
-          </a:p>
-          <a:p>
-            <a:pPr marL="285750" indent="-285750" algn="l">
-              <a:spcBef>
-                <a:spcPts val="400"/>
-              </a:spcBef>
-              <a:buFont typeface="Arial" panose="020B0604020202020204" pitchFamily="34" charset="0"/>
-              <a:buChar char="•"/>
-            </a:pPr>
-            <a:r>
-              <a:rPr lang="en-US" sz="1350" b="0" i="0" dirty="0">
-                <a:latin typeface="Calibri" panose="020F0502020204030204" pitchFamily="34" charset="0"/>
-                <a:ea typeface="Calibri" panose="020F0502020204030204" pitchFamily="34" charset="0"/>
-                <a:cs typeface="Calibri" panose="020F0502020204030204" pitchFamily="34" charset="0"/>
-              </a:rPr>
-              <a:t>Model and data versioning, plus a retraining trigger — the components practitioners named as prerequisites.</a:t>
-            </a:r>
-          </a:p>
-          <a:p>
-            <a:pPr marL="285750" indent="-285750" algn="l">
-              <a:spcBef>
-                <a:spcPts val="400"/>
-              </a:spcBef>
-              <a:buFont typeface="Arial" panose="020B0604020202020204" pitchFamily="34" charset="0"/>
-              <a:buChar char="•"/>
-            </a:pPr>
-            <a:r>
-              <a:rPr lang="en-US" sz="1350" b="0" i="0" dirty="0">
-                <a:latin typeface="Calibri" panose="020F0502020204030204" pitchFamily="34" charset="0"/>
-                <a:ea typeface="Calibri" panose="020F0502020204030204" pitchFamily="34" charset="0"/>
-                <a:cs typeface="Calibri" panose="020F0502020204030204" pitchFamily="34" charset="0"/>
-              </a:rPr>
-              <a:t>Load-test the gateway under concurrency to confirm the p99 budget at realistic volume.</a:t>
-            </a:r>
-          </a:p>
-          <a:p>
-            <a:pPr marL="285750" indent="-285750" algn="l">
-              <a:spcBef>
-                <a:spcPts val="400"/>
-              </a:spcBef>
-              <a:buFont typeface="Arial" panose="020B0604020202020204" pitchFamily="34" charset="0"/>
-              <a:buChar char="•"/>
-            </a:pPr>
-            <a:r>
-              <a:rPr lang="en-US" sz="1350" b="0" i="0" dirty="0">
-                <a:latin typeface="Calibri" panose="020F0502020204030204" pitchFamily="34" charset="0"/>
-                <a:ea typeface="Calibri" panose="020F0502020204030204" pitchFamily="34" charset="0"/>
-                <a:cs typeface="Calibri" panose="020F0502020204030204" pitchFamily="34" charset="0"/>
-              </a:rPr>
-              <a:t>Shadow-mode onboarding with two to three partner startups.</a:t>
+              <a:t>A thermometer is not validated by pointing it at random objects. It goes into melting ice to read 0 °C and boiling water to read 100 °C. The reference points have to be known, or the reading cannot be checked against anything.</a:t>
             </a:r>
           </a:p>
         </p:txBody>
@@ -6731,7 +6669,7 @@
           <a:p>
             <a:fld id="{64C96E34-94C0-49E4-A53B-4A44141FD3C8}" type="datetime3">
               <a:rPr lang="en-US" smtClean="0"/>
-              <a:t>4 September 2026</a:t>
+              <a:t>12 September 2026</a:t>
             </a:fld>
             <a:endParaRPr lang="en-US" dirty="0"/>
           </a:p>
@@ -6761,7 +6699,7 @@
             <a:fld id="{D57F1E4F-1CFF-5643-939E-217C01CDF565}" type="slidenum">
               <a:rPr lang="en-US" smtClean="0"/>
               <a:pPr/>
-              <a:t>9</a:t>
+              <a:t>3</a:t>
             </a:fld>
             <a:endParaRPr lang="en-US" dirty="0"/>
           </a:p>
@@ -6805,8 +6743,8 @@
           <p:nvPr/>
         </p:nvGraphicFramePr>
         <p:xfrm>
-          <a:off x="960120" y="4206240"/>
-          <a:ext cx="10241279" cy="101600"/>
+          <a:off x="960120" y="3931920"/>
+          <a:ext cx="10241278" cy="76200"/>
         </p:xfrm>
         <a:graphic>
           <a:graphicData uri="http://schemas.openxmlformats.org/drawingml/2006/table">
@@ -6815,9 +6753,11 @@
                 <a:tableStyleId>{5C22544A-7EE6-4342-B048-85BDC9FD1C3A}</a:tableStyleId>
               </a:tblPr>
               <a:tblGrid>
-                <a:gridCol w="2048256"/>
-                <a:gridCol w="1433779"/>
-                <a:gridCol w="6759244"/>
+                <a:gridCol w="1126540"/>
+                <a:gridCol w="3072384"/>
+                <a:gridCol w="1945843"/>
+                <a:gridCol w="2355494"/>
+                <a:gridCol w="1741017"/>
               </a:tblGrid>
               <a:tr h="25400">
                 <a:tc>
@@ -6832,7 +6772,7 @@
                           </a:solidFill>
                           <a:latin typeface="Calibri"/>
                         </a:rPr>
-                        <a:t>Team member</a:t>
+                        <a:t/>
                       </a:r>
                     </a:p>
                   </a:txBody>
@@ -6854,7 +6794,7 @@
                           </a:solidFill>
                           <a:latin typeface="Calibri"/>
                         </a:rPr>
-                        <a:t>USN</a:t>
+                        <a:t>Data used</a:t>
                       </a:r>
                     </a:p>
                   </a:txBody>
@@ -6876,7 +6816,7 @@
                           </a:solidFill>
                           <a:latin typeface="Calibri"/>
                         </a:rPr>
-                        <a:t>Modules owned</a:t>
+                        <a:t>Question it answers</a:t>
                       </a:r>
                     </a:p>
                   </a:txBody>
@@ -6886,6 +6826,50 @@
                     </a:solidFill>
                   </a:tcPr>
                 </a:tc>
+                <a:tc>
+                  <a:txBody>
+                    <a:bodyPr wrap="square"/>
+                    <a:lstStyle/>
+                    <a:p>
+                      <a:r>
+                        <a:rPr sz="1100" b="1">
+                          <a:solidFill>
+                            <a:srgbClr val="FFFFFF"/>
+                          </a:solidFill>
+                          <a:latin typeface="Calibri"/>
+                        </a:rPr>
+                        <a:t>Ground truth</a:t>
+                      </a:r>
+                    </a:p>
+                  </a:txBody>
+                  <a:tcPr marL="63500" marR="63500" marT="38100" marB="38100">
+                    <a:solidFill>
+                      <a:srgbClr val="1F5CA8"/>
+                    </a:solidFill>
+                  </a:tcPr>
+                </a:tc>
+                <a:tc>
+                  <a:txBody>
+                    <a:bodyPr wrap="square"/>
+                    <a:lstStyle/>
+                    <a:p>
+                      <a:r>
+                        <a:rPr sz="1100" b="1">
+                          <a:solidFill>
+                            <a:srgbClr val="FFFFFF"/>
+                          </a:solidFill>
+                          <a:latin typeface="Calibri"/>
+                        </a:rPr>
+                        <a:t>Status</a:t>
+                      </a:r>
+                    </a:p>
+                  </a:txBody>
+                  <a:tcPr marL="63500" marR="63500" marT="38100" marB="38100">
+                    <a:solidFill>
+                      <a:srgbClr val="1F5CA8"/>
+                    </a:solidFill>
+                  </a:tcPr>
+                </a:tc>
               </a:tr>
               <a:tr h="25400">
                 <a:tc>
@@ -6897,7 +6881,7 @@
                         <a:rPr sz="1100" b="0">
                           <a:latin typeface="Calibri"/>
                         </a:rPr>
-                        <a:t>AYUSH PANDEY</a:t>
+                        <a:t>Calibration</a:t>
                       </a:r>
                     </a:p>
                   </a:txBody>
@@ -6914,7 +6898,7 @@
                         <a:rPr sz="1100" b="0">
                           <a:latin typeface="Calibri"/>
                         </a:rPr>
-                        <a:t>1BM23AD074</a:t>
+                        <a:t>Controlled distributions with shifts of a chosen size, injected into the demo's own feature population</a:t>
                       </a:r>
                     </a:p>
                   </a:txBody>
@@ -6931,7 +6915,7 @@
                         <a:rPr sz="1100" b="0">
                           <a:latin typeface="Calibri"/>
                         </a:rPr>
-                        <a:t>Architecture and ADRs · drift engine (PSI/KS detectors, severity roll-up, offline worker) · trust engine fusion and decision matrix</a:t>
+                        <a:t>Is the detector correct?</a:t>
                       </a:r>
                     </a:p>
                   </a:txBody>
@@ -6939,6 +6923,40 @@
                     <a:noFill/>
                   </a:tcPr>
                 </a:tc>
+                <a:tc>
+                  <a:txBody>
+                    <a:bodyPr wrap="square"/>
+                    <a:lstStyle/>
+                    <a:p>
+                      <a:r>
+                        <a:rPr sz="1100" b="0">
+                          <a:latin typeface="Calibri"/>
+                        </a:rPr>
+                        <a:t>Known — we chose the shift, so the right answer exists</a:t>
+                      </a:r>
+                    </a:p>
+                  </a:txBody>
+                  <a:tcPr marL="63500" marR="63500" marT="38100" marB="38100">
+                    <a:noFill/>
+                  </a:tcPr>
+                </a:tc>
+                <a:tc>
+                  <a:txBody>
+                    <a:bodyPr wrap="square"/>
+                    <a:lstStyle/>
+                    <a:p>
+                      <a:r>
+                        <a:rPr sz="1100" b="0">
+                          <a:latin typeface="Calibri"/>
+                        </a:rPr>
+                        <a:t>Done · 43 detector tests</a:t>
+                      </a:r>
+                    </a:p>
+                  </a:txBody>
+                  <a:tcPr marL="63500" marR="63500" marT="38100" marB="38100">
+                    <a:noFill/>
+                  </a:tcPr>
+                </a:tc>
               </a:tr>
               <a:tr h="25400">
                 <a:tc>
@@ -6950,7 +6968,7 @@
                         <a:rPr sz="1100" b="0">
                           <a:latin typeface="Calibri"/>
                         </a:rPr>
-                        <a:t>VIVEK BOORA</a:t>
+                        <a:t>Field</a:t>
                       </a:r>
                     </a:p>
                   </a:txBody>
@@ -6969,7 +6987,7 @@
                         <a:rPr sz="1100" b="0">
                           <a:latin typeface="Calibri"/>
                         </a:rPr>
-                        <a:t>1BM23AD073</a:t>
+                        <a:t>Public real-world credit data, replayed in time order through the same drift code the gateway runs</a:t>
                       </a:r>
                     </a:p>
                   </a:txBody>
@@ -6988,7 +7006,7 @@
                         <a:rPr sz="1100" b="0">
                           <a:latin typeface="Calibri"/>
                         </a:rPr>
-                        <a:t>Gateway and control-plane APIs · policy engine and rule grammar · tamper-evident audit chain and evidence export</a:t>
+                        <a:t>Does it fire on drift that actually happened?</a:t>
                       </a:r>
                     </a:p>
                   </a:txBody>
@@ -6998,8 +7016,6 @@
                     </a:solidFill>
                   </a:tcPr>
                 </a:tc>
-              </a:tr>
-              <a:tr h="25400">
                 <a:tc>
                   <a:txBody>
                     <a:bodyPr wrap="square"/>
@@ -7009,12 +7025,14 @@
                         <a:rPr sz="1100" b="0">
                           <a:latin typeface="Calibri"/>
                         </a:rPr>
-                        <a:t>NITIN</a:t>
+                        <a:t>Unknown — but nobody chose the drift, which is what makes it fair</a:t>
                       </a:r>
                     </a:p>
                   </a:txBody>
                   <a:tcPr marL="63500" marR="63500" marT="38100" marB="38100">
-                    <a:noFill/>
+                    <a:solidFill>
+                      <a:srgbClr val="F4F6F9"/>
+                    </a:solidFill>
                   </a:tcPr>
                 </a:tc>
                 <a:tc>
@@ -7026,29 +7044,14 @@
                         <a:rPr sz="1100" b="0">
                           <a:latin typeface="Calibri"/>
                         </a:rPr>
-                        <a:t>1BM24AD404</a:t>
+                        <a:t>Harness built · Lending Club run is Review-2</a:t>
                       </a:r>
                     </a:p>
                   </a:txBody>
                   <a:tcPr marL="63500" marR="63500" marT="38100" marB="38100">
-                    <a:noFill/>
-                  </a:tcPr>
-                </a:tc>
-                <a:tc>
-                  <a:txBody>
-                    <a:bodyPr wrap="square"/>
-                    <a:lstStyle/>
-                    <a:p>
-                      <a:r>
-                        <a:rPr sz="1100" b="0">
-                          <a:latin typeface="Calibri"/>
-                        </a:rPr>
-                        <a:t>Python SDK · React operator dashboard · fintech demonstration · 268-test suite across unit, integration and end-to-end</a:t>
-                      </a:r>
-                    </a:p>
-                  </a:txBody>
-                  <a:tcPr marL="63500" marR="63500" marT="38100" marB="38100">
-                    <a:noFill/>
+                    <a:solidFill>
+                      <a:srgbClr val="F4F6F9"/>
+                    </a:solidFill>
                   </a:tcPr>
                 </a:tc>
               </a:tr>
@@ -7059,7 +7062,1159 @@
     </p:spTree>
     <p:extLst>
       <p:ext uri="{BB962C8B-B14F-4D97-AF65-F5344CB8AC3E}">
-        <p14:creationId xmlns:p14="http://schemas.microsoft.com/office/powerpoint/2010/main" val="68599917"/>
+        <p14:creationId xmlns:p14="http://schemas.microsoft.com/office/powerpoint/2010/main" val="3231882420"/>
+      </p:ext>
+    </p:extLst>
+  </p:cSld>
+  <p:clrMapOvr>
+    <a:masterClrMapping/>
+  </p:clrMapOvr>
+</p:sld>
+</file>
+
+<file path=ppt/slides/slide17.xml><?xml version="1.0" encoding="utf-8"?>
+<p:sld xmlns:a="http://schemas.openxmlformats.org/drawingml/2006/main" xmlns:r="http://schemas.openxmlformats.org/officeDocument/2006/relationships" xmlns:p="http://schemas.openxmlformats.org/presentationml/2006/main">
+  <p:cSld>
+    <p:spTree>
+      <p:nvGrpSpPr>
+        <p:cNvPr id="1" name=""/>
+        <p:cNvGrpSpPr/>
+        <p:nvPr/>
+      </p:nvGrpSpPr>
+      <p:grpSpPr>
+        <a:xfrm>
+          <a:off x="0" y="0"/>
+          <a:ext cx="0" cy="0"/>
+          <a:chOff x="0" y="0"/>
+          <a:chExt cx="0" cy="0"/>
+        </a:xfrm>
+      </p:grpSpPr>
+      <p:sp>
+        <p:nvSpPr>
+          <p:cNvPr id="2" name="Title 1">
+            <a:extLst>
+              <a:ext uri="{FF2B5EF4-FFF2-40B4-BE49-F238E27FC236}">
+                <a16:creationId xmlns:a16="http://schemas.microsoft.com/office/drawing/2014/main" id="{BD1A189D-22D1-4D1A-9E04-C6134EC51F8B}"/>
+              </a:ext>
+            </a:extLst>
+          </p:cNvPr>
+          <p:cNvSpPr>
+            <a:spLocks noGrp="1"/>
+          </p:cNvSpPr>
+          <p:nvPr>
+            <p:ph type="ctrTitle"/>
+          </p:nvPr>
+        </p:nvSpPr>
+        <p:spPr>
+          <a:xfrm>
+            <a:off x="1684868" y="203198"/>
+            <a:ext cx="9694332" cy="880535"/>
+          </a:xfrm>
+        </p:spPr>
+        <p:txBody>
+          <a:bodyPr>
+            <a:normAutofit/>
+          </a:bodyPr>
+          <a:lstStyle/>
+          <a:p>
+            <a:pPr marL="0" indent="0" algn="l">
+              <a:spcBef>
+                <a:spcPts val="0"/>
+              </a:spcBef>
+              <a:buNone/>
+            </a:pPr>
+            <a:r>
+              <a:rPr lang="en-US" sz="3200" b="1" i="0" dirty="0">
+                <a:latin typeface="Calibri" panose="020F0502020204030204" pitchFamily="34" charset="0"/>
+                <a:ea typeface="Calibri" panose="020F0502020204030204" pitchFamily="34" charset="0"/>
+                <a:cs typeface="Calibri" panose="020F0502020204030204" pitchFamily="34" charset="0"/>
+              </a:rPr>
+              <a:t>Calibration — the Instrument in Ice and Steam</a:t>
+            </a:r>
+          </a:p>
+        </p:txBody>
+      </p:sp>
+      <p:sp>
+        <p:nvSpPr>
+          <p:cNvPr id="3" name="Subtitle 2">
+            <a:extLst>
+              <a:ext uri="{FF2B5EF4-FFF2-40B4-BE49-F238E27FC236}">
+                <a16:creationId xmlns:a16="http://schemas.microsoft.com/office/drawing/2014/main" id="{255E737C-85F2-47BC-AD38-AD8B001473B7}"/>
+              </a:ext>
+            </a:extLst>
+          </p:cNvPr>
+          <p:cNvSpPr>
+            <a:spLocks noGrp="1"/>
+          </p:cNvSpPr>
+          <p:nvPr>
+            <p:ph type="subTitle" idx="1"/>
+          </p:nvPr>
+        </p:nvSpPr>
+        <p:spPr>
+          <a:xfrm>
+            <a:off x="1684867" y="1574800"/>
+            <a:ext cx="9694333" cy="4614333"/>
+          </a:xfrm>
+        </p:spPr>
+        <p:txBody>
+          <a:bodyPr>
+            <a:normAutofit/>
+          </a:bodyPr>
+          <a:lstStyle/>
+          <a:p>
+            <a:pPr marL="0" indent="0" algn="l">
+              <a:spcBef>
+                <a:spcPts val="0"/>
+              </a:spcBef>
+              <a:buNone/>
+            </a:pPr>
+            <a:r>
+              <a:rPr lang="en-US" sz="1400" b="0" i="0" dirty="0">
+                <a:latin typeface="Calibri" panose="020F0502020204030204" pitchFamily="34" charset="0"/>
+                <a:ea typeface="Calibri" panose="020F0502020204030204" pitchFamily="34" charset="0"/>
+                <a:cs typeface="Calibri" panose="020F0502020204030204" pitchFamily="34" charset="0"/>
+              </a:rPr>
+              <a:t>Shift a feature's mean by a chosen number of standard deviations and check what PSI reports back. Because the input was chosen, the correct output is known — which is precisely what real data cannot offer.</a:t>
+            </a:r>
+          </a:p>
+        </p:txBody>
+      </p:sp>
+      <p:pic>
+        <p:nvPicPr>
+          <p:cNvPr id="5" name="Graphic 4">
+            <a:extLst>
+              <a:ext uri="{FF2B5EF4-FFF2-40B4-BE49-F238E27FC236}">
+                <a16:creationId xmlns:a16="http://schemas.microsoft.com/office/drawing/2014/main" id="{E7125167-8301-4D88-B79A-A8DA3C19E0D6}"/>
+              </a:ext>
+            </a:extLst>
+          </p:cNvPr>
+          <p:cNvPicPr>
+            <a:picLocks noChangeAspect="1"/>
+          </p:cNvPicPr>
+          <p:nvPr/>
+        </p:nvPicPr>
+        <p:blipFill>
+          <a:blip r:embed="rId2">
+            <a:extLst>
+              <a:ext uri="{96DAC541-7B7A-43D3-8B79-37D633B846F1}">
+                <asvg:svgBlip xmlns:asvg="http://schemas.microsoft.com/office/drawing/2016/SVG/main" r:embed="rId3"/>
+              </a:ext>
+            </a:extLst>
+          </a:blip>
+          <a:stretch>
+            <a:fillRect/>
+          </a:stretch>
+        </p:blipFill>
+        <p:spPr>
+          <a:xfrm>
+            <a:off x="127001" y="86782"/>
+            <a:ext cx="1159932" cy="1159932"/>
+          </a:xfrm>
+          <a:prstGeom prst="rect">
+            <a:avLst/>
+          </a:prstGeom>
+        </p:spPr>
+      </p:pic>
+      <p:sp>
+        <p:nvSpPr>
+          <p:cNvPr id="4" name="Date Placeholder 3">
+            <a:extLst>
+              <a:ext uri="{FF2B5EF4-FFF2-40B4-BE49-F238E27FC236}">
+                <a16:creationId xmlns:a16="http://schemas.microsoft.com/office/drawing/2014/main" id="{35032362-C5A5-4DBF-AD79-DE6FB7439999}"/>
+              </a:ext>
+            </a:extLst>
+          </p:cNvPr>
+          <p:cNvSpPr>
+            <a:spLocks noGrp="1"/>
+          </p:cNvSpPr>
+          <p:nvPr>
+            <p:ph type="dt" sz="half" idx="10"/>
+          </p:nvPr>
+        </p:nvSpPr>
+        <p:spPr/>
+        <p:txBody>
+          <a:bodyPr/>
+          <a:lstStyle/>
+          <a:p>
+            <a:fld id="{64C96E34-94C0-49E4-A53B-4A44141FD3C8}" type="datetime3">
+              <a:rPr lang="en-US" smtClean="0"/>
+              <a:t>12 September 2026</a:t>
+            </a:fld>
+            <a:endParaRPr lang="en-US" dirty="0"/>
+          </a:p>
+        </p:txBody>
+      </p:sp>
+      <p:sp>
+        <p:nvSpPr>
+          <p:cNvPr id="6" name="Slide Number Placeholder 5">
+            <a:extLst>
+              <a:ext uri="{FF2B5EF4-FFF2-40B4-BE49-F238E27FC236}">
+                <a16:creationId xmlns:a16="http://schemas.microsoft.com/office/drawing/2014/main" id="{115AAB64-5B51-4B5A-B69E-D96362CE6E74}"/>
+              </a:ext>
+            </a:extLst>
+          </p:cNvPr>
+          <p:cNvSpPr>
+            <a:spLocks noGrp="1"/>
+          </p:cNvSpPr>
+          <p:nvPr>
+            <p:ph type="sldNum" sz="quarter" idx="12"/>
+          </p:nvPr>
+        </p:nvSpPr>
+        <p:spPr/>
+        <p:txBody>
+          <a:bodyPr/>
+          <a:lstStyle/>
+          <a:p>
+            <a:fld id="{D57F1E4F-1CFF-5643-939E-217C01CDF565}" type="slidenum">
+              <a:rPr lang="en-US" smtClean="0"/>
+              <a:pPr/>
+              <a:t>3</a:t>
+            </a:fld>
+            <a:endParaRPr lang="en-US" dirty="0"/>
+          </a:p>
+        </p:txBody>
+      </p:sp>
+      <p:sp>
+        <p:nvSpPr>
+          <p:cNvPr id="7" name="Footer Placeholder 6">
+            <a:extLst>
+              <a:ext uri="{FF2B5EF4-FFF2-40B4-BE49-F238E27FC236}">
+                <a16:creationId xmlns:a16="http://schemas.microsoft.com/office/drawing/2014/main" id="{8683C6DF-27D9-468B-A1AB-FE568488FE57}"/>
+              </a:ext>
+            </a:extLst>
+          </p:cNvPr>
+          <p:cNvSpPr>
+            <a:spLocks noGrp="1"/>
+          </p:cNvSpPr>
+          <p:nvPr>
+            <p:ph type="ftr" sz="quarter" idx="11"/>
+          </p:nvPr>
+        </p:nvSpPr>
+        <p:spPr/>
+        <p:txBody>
+          <a:bodyPr/>
+          <a:lstStyle/>
+          <a:p>
+            <a:r>
+              <a:rPr lang="en-US"/>
+              <a:t>Dept of AI &amp; DS</a:t>
+            </a:r>
+            <a:endParaRPr lang="en-US" dirty="0"/>
+          </a:p>
+        </p:txBody>
+      </p:sp>
+      <p:pic>
+        <p:nvPicPr>
+          <p:cNvPr id="8" name="Picture 7" descr="calibration_curve.png"/>
+          <p:cNvPicPr>
+            <a:picLocks noChangeAspect="1"/>
+          </p:cNvPicPr>
+          <p:nvPr/>
+        </p:nvPicPr>
+        <p:blipFill>
+          <a:blip r:embed="rId4"/>
+          <a:stretch>
+            <a:fillRect/>
+          </a:stretch>
+        </p:blipFill>
+        <p:spPr>
+          <a:xfrm>
+            <a:off x="1066647" y="2514600"/>
+            <a:ext cx="10058400" cy="3154680"/>
+          </a:xfrm>
+          <a:prstGeom prst="rect">
+            <a:avLst/>
+          </a:prstGeom>
+        </p:spPr>
+      </p:pic>
+    </p:spTree>
+    <p:extLst>
+      <p:ext uri="{BB962C8B-B14F-4D97-AF65-F5344CB8AC3E}">
+        <p14:creationId xmlns:p14="http://schemas.microsoft.com/office/powerpoint/2010/main" val="3231882420"/>
+      </p:ext>
+    </p:extLst>
+  </p:cSld>
+  <p:clrMapOvr>
+    <a:masterClrMapping/>
+  </p:clrMapOvr>
+</p:sld>
+</file>
+
+<file path=ppt/slides/slide18.xml><?xml version="1.0" encoding="utf-8"?>
+<p:sld xmlns:a="http://schemas.openxmlformats.org/drawingml/2006/main" xmlns:r="http://schemas.openxmlformats.org/officeDocument/2006/relationships" xmlns:p="http://schemas.openxmlformats.org/presentationml/2006/main">
+  <p:cSld>
+    <p:spTree>
+      <p:nvGrpSpPr>
+        <p:cNvPr id="1" name=""/>
+        <p:cNvGrpSpPr/>
+        <p:nvPr/>
+      </p:nvGrpSpPr>
+      <p:grpSpPr>
+        <a:xfrm>
+          <a:off x="0" y="0"/>
+          <a:ext cx="0" cy="0"/>
+          <a:chOff x="0" y="0"/>
+          <a:chExt cx="0" cy="0"/>
+        </a:xfrm>
+      </p:grpSpPr>
+      <p:sp>
+        <p:nvSpPr>
+          <p:cNvPr id="2" name="Title 1">
+            <a:extLst>
+              <a:ext uri="{FF2B5EF4-FFF2-40B4-BE49-F238E27FC236}">
+                <a16:creationId xmlns:a16="http://schemas.microsoft.com/office/drawing/2014/main" id="{BD1A189D-22D1-4D1A-9E04-C6134EC51F8B}"/>
+              </a:ext>
+            </a:extLst>
+          </p:cNvPr>
+          <p:cNvSpPr>
+            <a:spLocks noGrp="1"/>
+          </p:cNvSpPr>
+          <p:nvPr>
+            <p:ph type="ctrTitle"/>
+          </p:nvPr>
+        </p:nvSpPr>
+        <p:spPr>
+          <a:xfrm>
+            <a:off x="1684868" y="203198"/>
+            <a:ext cx="9694332" cy="880535"/>
+          </a:xfrm>
+        </p:spPr>
+        <p:txBody>
+          <a:bodyPr>
+            <a:normAutofit/>
+          </a:bodyPr>
+          <a:lstStyle/>
+          <a:p>
+            <a:pPr marL="0" indent="0" algn="l">
+              <a:spcBef>
+                <a:spcPts val="0"/>
+              </a:spcBef>
+              <a:buNone/>
+            </a:pPr>
+            <a:r>
+              <a:rPr lang="en-US" sz="3200" b="1" i="0" dirty="0">
+                <a:latin typeface="Calibri" panose="020F0502020204030204" pitchFamily="34" charset="0"/>
+                <a:ea typeface="Calibri" panose="020F0502020204030204" pitchFamily="34" charset="0"/>
+                <a:cs typeface="Calibri" panose="020F0502020204030204" pitchFamily="34" charset="0"/>
+              </a:rPr>
+              <a:t>What the Controlled Data Proves</a:t>
+            </a:r>
+          </a:p>
+        </p:txBody>
+      </p:sp>
+      <p:sp>
+        <p:nvSpPr>
+          <p:cNvPr id="3" name="Subtitle 2">
+            <a:extLst>
+              <a:ext uri="{FF2B5EF4-FFF2-40B4-BE49-F238E27FC236}">
+                <a16:creationId xmlns:a16="http://schemas.microsoft.com/office/drawing/2014/main" id="{255E737C-85F2-47BC-AD38-AD8B001473B7}"/>
+              </a:ext>
+            </a:extLst>
+          </p:cNvPr>
+          <p:cNvSpPr>
+            <a:spLocks noGrp="1"/>
+          </p:cNvSpPr>
+          <p:nvPr>
+            <p:ph type="subTitle" idx="1"/>
+          </p:nvPr>
+        </p:nvSpPr>
+        <p:spPr>
+          <a:xfrm>
+            <a:off x="1684867" y="1574800"/>
+            <a:ext cx="9694333" cy="4614333"/>
+          </a:xfrm>
+        </p:spPr>
+        <p:txBody>
+          <a:bodyPr>
+            <a:normAutofit/>
+          </a:bodyPr>
+          <a:lstStyle/>
+          <a:p>
+            <a:pPr marL="0" indent="0" algn="l">
+              <a:spcBef>
+                <a:spcPts val="0"/>
+              </a:spcBef>
+              <a:buNone/>
+            </a:pPr>
+            <a:r>
+              <a:rPr lang="en-US" sz="1400" b="0" i="0" dirty="0">
+                <a:latin typeface="Calibri" panose="020F0502020204030204" pitchFamily="34" charset="0"/>
+                <a:ea typeface="Calibri" panose="020F0502020204030204" pitchFamily="34" charset="0"/>
+                <a:cs typeface="Calibri" panose="020F0502020204030204" pitchFamily="34" charset="0"/>
+              </a:rPr>
+              <a:t>Five properties, 43 detector tests. The right-hand column is the answer to “why not just use a real dataset?” — none of these could be checked on one.</a:t>
+            </a:r>
+          </a:p>
+        </p:txBody>
+      </p:sp>
+      <p:pic>
+        <p:nvPicPr>
+          <p:cNvPr id="5" name="Graphic 4">
+            <a:extLst>
+              <a:ext uri="{FF2B5EF4-FFF2-40B4-BE49-F238E27FC236}">
+                <a16:creationId xmlns:a16="http://schemas.microsoft.com/office/drawing/2014/main" id="{E7125167-8301-4D88-B79A-A8DA3C19E0D6}"/>
+              </a:ext>
+            </a:extLst>
+          </p:cNvPr>
+          <p:cNvPicPr>
+            <a:picLocks noChangeAspect="1"/>
+          </p:cNvPicPr>
+          <p:nvPr/>
+        </p:nvPicPr>
+        <p:blipFill>
+          <a:blip r:embed="rId2">
+            <a:extLst>
+              <a:ext uri="{96DAC541-7B7A-43D3-8B79-37D633B846F1}">
+                <asvg:svgBlip xmlns:asvg="http://schemas.microsoft.com/office/drawing/2016/SVG/main" r:embed="rId3"/>
+              </a:ext>
+            </a:extLst>
+          </a:blip>
+          <a:stretch>
+            <a:fillRect/>
+          </a:stretch>
+        </p:blipFill>
+        <p:spPr>
+          <a:xfrm>
+            <a:off x="127001" y="86782"/>
+            <a:ext cx="1159932" cy="1159932"/>
+          </a:xfrm>
+          <a:prstGeom prst="rect">
+            <a:avLst/>
+          </a:prstGeom>
+        </p:spPr>
+      </p:pic>
+      <p:sp>
+        <p:nvSpPr>
+          <p:cNvPr id="4" name="Date Placeholder 3">
+            <a:extLst>
+              <a:ext uri="{FF2B5EF4-FFF2-40B4-BE49-F238E27FC236}">
+                <a16:creationId xmlns:a16="http://schemas.microsoft.com/office/drawing/2014/main" id="{35032362-C5A5-4DBF-AD79-DE6FB7439999}"/>
+              </a:ext>
+            </a:extLst>
+          </p:cNvPr>
+          <p:cNvSpPr>
+            <a:spLocks noGrp="1"/>
+          </p:cNvSpPr>
+          <p:nvPr>
+            <p:ph type="dt" sz="half" idx="10"/>
+          </p:nvPr>
+        </p:nvSpPr>
+        <p:spPr/>
+        <p:txBody>
+          <a:bodyPr/>
+          <a:lstStyle/>
+          <a:p>
+            <a:fld id="{64C96E34-94C0-49E4-A53B-4A44141FD3C8}" type="datetime3">
+              <a:rPr lang="en-US" smtClean="0"/>
+              <a:t>12 September 2026</a:t>
+            </a:fld>
+            <a:endParaRPr lang="en-US" dirty="0"/>
+          </a:p>
+        </p:txBody>
+      </p:sp>
+      <p:sp>
+        <p:nvSpPr>
+          <p:cNvPr id="6" name="Slide Number Placeholder 5">
+            <a:extLst>
+              <a:ext uri="{FF2B5EF4-FFF2-40B4-BE49-F238E27FC236}">
+                <a16:creationId xmlns:a16="http://schemas.microsoft.com/office/drawing/2014/main" id="{115AAB64-5B51-4B5A-B69E-D96362CE6E74}"/>
+              </a:ext>
+            </a:extLst>
+          </p:cNvPr>
+          <p:cNvSpPr>
+            <a:spLocks noGrp="1"/>
+          </p:cNvSpPr>
+          <p:nvPr>
+            <p:ph type="sldNum" sz="quarter" idx="12"/>
+          </p:nvPr>
+        </p:nvSpPr>
+        <p:spPr/>
+        <p:txBody>
+          <a:bodyPr/>
+          <a:lstStyle/>
+          <a:p>
+            <a:fld id="{D57F1E4F-1CFF-5643-939E-217C01CDF565}" type="slidenum">
+              <a:rPr lang="en-US" smtClean="0"/>
+              <a:pPr/>
+              <a:t>3</a:t>
+            </a:fld>
+            <a:endParaRPr lang="en-US" dirty="0"/>
+          </a:p>
+        </p:txBody>
+      </p:sp>
+      <p:sp>
+        <p:nvSpPr>
+          <p:cNvPr id="7" name="Footer Placeholder 6">
+            <a:extLst>
+              <a:ext uri="{FF2B5EF4-FFF2-40B4-BE49-F238E27FC236}">
+                <a16:creationId xmlns:a16="http://schemas.microsoft.com/office/drawing/2014/main" id="{8683C6DF-27D9-468B-A1AB-FE568488FE57}"/>
+              </a:ext>
+            </a:extLst>
+          </p:cNvPr>
+          <p:cNvSpPr>
+            <a:spLocks noGrp="1"/>
+          </p:cNvSpPr>
+          <p:nvPr>
+            <p:ph type="ftr" sz="quarter" idx="11"/>
+          </p:nvPr>
+        </p:nvSpPr>
+        <p:spPr/>
+        <p:txBody>
+          <a:bodyPr/>
+          <a:lstStyle/>
+          <a:p>
+            <a:r>
+              <a:rPr lang="en-US"/>
+              <a:t>Dept of AI &amp; DS</a:t>
+            </a:r>
+            <a:endParaRPr lang="en-US" dirty="0"/>
+          </a:p>
+        </p:txBody>
+      </p:sp>
+      <p:graphicFrame>
+        <p:nvGraphicFramePr>
+          <p:cNvPr id="8" name="Table 7"/>
+          <p:cNvGraphicFramePr>
+            <a:graphicFrameLocks noGrp="1"/>
+          </p:cNvGraphicFramePr>
+          <p:nvPr/>
+        </p:nvGraphicFramePr>
+        <p:xfrm>
+          <a:off x="960120" y="2468880"/>
+          <a:ext cx="10241278" cy="152400"/>
+        </p:xfrm>
+        <a:graphic>
+          <a:graphicData uri="http://schemas.openxmlformats.org/drawingml/2006/table">
+            <a:tbl>
+              <a:tblPr firstRow="1">
+                <a:tableStyleId>{5C22544A-7EE6-4342-B048-85BDC9FD1C3A}</a:tableStyleId>
+              </a:tblPr>
+              <a:tblGrid>
+                <a:gridCol w="2253081"/>
+                <a:gridCol w="4710988"/>
+                <a:gridCol w="3277209"/>
+              </a:tblGrid>
+              <a:tr h="25400">
+                <a:tc>
+                  <a:txBody>
+                    <a:bodyPr wrap="square"/>
+                    <a:lstStyle/>
+                    <a:p>
+                      <a:r>
+                        <a:rPr sz="1100" b="1">
+                          <a:solidFill>
+                            <a:srgbClr val="FFFFFF"/>
+                          </a:solidFill>
+                          <a:latin typeface="Calibri"/>
+                        </a:rPr>
+                        <a:t>What is checked</a:t>
+                      </a:r>
+                    </a:p>
+                  </a:txBody>
+                  <a:tcPr marL="63500" marR="63500" marT="38100" marB="38100">
+                    <a:solidFill>
+                      <a:srgbClr val="1F5CA8"/>
+                    </a:solidFill>
+                  </a:tcPr>
+                </a:tc>
+                <a:tc>
+                  <a:txBody>
+                    <a:bodyPr wrap="square"/>
+                    <a:lstStyle/>
+                    <a:p>
+                      <a:r>
+                        <a:rPr sz="1100" b="1">
+                          <a:solidFill>
+                            <a:srgbClr val="FFFFFF"/>
+                          </a:solidFill>
+                          <a:latin typeface="Calibri"/>
+                        </a:rPr>
+                        <a:t>How</a:t>
+                      </a:r>
+                    </a:p>
+                  </a:txBody>
+                  <a:tcPr marL="63500" marR="63500" marT="38100" marB="38100">
+                    <a:solidFill>
+                      <a:srgbClr val="1F5CA8"/>
+                    </a:solidFill>
+                  </a:tcPr>
+                </a:tc>
+                <a:tc>
+                  <a:txBody>
+                    <a:bodyPr wrap="square"/>
+                    <a:lstStyle/>
+                    <a:p>
+                      <a:r>
+                        <a:rPr sz="1100" b="1">
+                          <a:solidFill>
+                            <a:srgbClr val="FFFFFF"/>
+                          </a:solidFill>
+                          <a:latin typeface="Calibri"/>
+                        </a:rPr>
+                        <a:t>Why it could not be done on real data</a:t>
+                      </a:r>
+                    </a:p>
+                  </a:txBody>
+                  <a:tcPr marL="63500" marR="63500" marT="38100" marB="38100">
+                    <a:solidFill>
+                      <a:srgbClr val="1F5CA8"/>
+                    </a:solidFill>
+                  </a:tcPr>
+                </a:tc>
+              </a:tr>
+              <a:tr h="25400">
+                <a:tc>
+                  <a:txBody>
+                    <a:bodyPr wrap="square"/>
+                    <a:lstStyle/>
+                    <a:p>
+                      <a:r>
+                        <a:rPr sz="1100" b="0">
+                          <a:latin typeface="Calibri"/>
+                        </a:rPr>
+                        <a:t>PSI is arithmetically right</a:t>
+                      </a:r>
+                    </a:p>
+                  </a:txBody>
+                  <a:tcPr marL="63500" marR="63500" marT="38100" marB="38100">
+                    <a:noFill/>
+                  </a:tcPr>
+                </a:tc>
+                <a:tc>
+                  <a:txBody>
+                    <a:bodyPr wrap="square"/>
+                    <a:lstStyle/>
+                    <a:p>
+                      <a:r>
+                        <a:rPr sz="1100" b="0">
+                          <a:latin typeface="Calibri"/>
+                        </a:rPr>
+                        <a:t>Checked against a value computed by hand from the definition; KS against a case where the CDF gap is exactly 0.5 by construction</a:t>
+                      </a:r>
+                    </a:p>
+                  </a:txBody>
+                  <a:tcPr marL="63500" marR="63500" marT="38100" marB="38100">
+                    <a:noFill/>
+                  </a:tcPr>
+                </a:tc>
+                <a:tc>
+                  <a:txBody>
+                    <a:bodyPr wrap="square"/>
+                    <a:lstStyle/>
+                    <a:p>
+                      <a:r>
+                        <a:rPr sz="1100" b="0">
+                          <a:latin typeface="Calibri"/>
+                        </a:rPr>
+                        <a:t>There is no hand-computable right answer for 2.2 million rows</a:t>
+                      </a:r>
+                    </a:p>
+                  </a:txBody>
+                  <a:tcPr marL="63500" marR="63500" marT="38100" marB="38100">
+                    <a:noFill/>
+                  </a:tcPr>
+                </a:tc>
+              </a:tr>
+              <a:tr h="25400">
+                <a:tc>
+                  <a:txBody>
+                    <a:bodyPr wrap="square"/>
+                    <a:lstStyle/>
+                    <a:p>
+                      <a:r>
+                        <a:rPr sz="1100" b="0">
+                          <a:latin typeface="Calibri"/>
+                        </a:rPr>
+                        <a:t>0σ reads stable</a:t>
+                      </a:r>
+                    </a:p>
+                  </a:txBody>
+                  <a:tcPr marL="63500" marR="63500" marT="38100" marB="38100">
+                    <a:solidFill>
+                      <a:srgbClr val="F4F6F9"/>
+                    </a:solidFill>
+                  </a:tcPr>
+                </a:tc>
+                <a:tc>
+                  <a:txBody>
+                    <a:bodyPr wrap="square"/>
+                    <a:lstStyle/>
+                    <a:p>
+                      <a:r>
+                        <a:rPr sz="1100" b="0">
+                          <a:latin typeface="Calibri"/>
+                        </a:rPr>
+                        <a:t>Two draws from the same distribution report PSI 0.030 — below the 0.10 stable band</a:t>
+                      </a:r>
+                    </a:p>
+                  </a:txBody>
+                  <a:tcPr marL="63500" marR="63500" marT="38100" marB="38100">
+                    <a:solidFill>
+                      <a:srgbClr val="F4F6F9"/>
+                    </a:solidFill>
+                  </a:tcPr>
+                </a:tc>
+                <a:tc>
+                  <a:txBody>
+                    <a:bodyPr wrap="square"/>
+                    <a:lstStyle/>
+                    <a:p>
+                      <a:r>
+                        <a:rPr sz="1100" b="0">
+                          <a:latin typeface="Calibri"/>
+                        </a:rPr>
+                        <a:t>No real dataset is known to contain zero drift</a:t>
+                      </a:r>
+                    </a:p>
+                  </a:txBody>
+                  <a:tcPr marL="63500" marR="63500" marT="38100" marB="38100">
+                    <a:solidFill>
+                      <a:srgbClr val="F4F6F9"/>
+                    </a:solidFill>
+                  </a:tcPr>
+                </a:tc>
+              </a:tr>
+              <a:tr h="25400">
+                <a:tc>
+                  <a:txBody>
+                    <a:bodyPr wrap="square"/>
+                    <a:lstStyle/>
+                    <a:p>
+                      <a:r>
+                        <a:rPr sz="1100" b="0">
+                          <a:latin typeface="Calibri"/>
+                        </a:rPr>
+                        <a:t>1σ reads significant</a:t>
+                      </a:r>
+                    </a:p>
+                  </a:txBody>
+                  <a:tcPr marL="63500" marR="63500" marT="38100" marB="38100">
+                    <a:noFill/>
+                  </a:tcPr>
+                </a:tc>
+                <a:tc>
+                  <a:txBody>
+                    <a:bodyPr wrap="square"/>
+                    <a:lstStyle/>
+                    <a:p>
+                      <a:r>
+                        <a:rPr sz="1100" b="0">
+                          <a:latin typeface="Calibri"/>
+                        </a:rPr>
+                        <a:t>A one-standard-deviation mean shift reports PSI 1.019 — 4× the 0.25 threshold a credit-risk team already uses</a:t>
+                      </a:r>
+                    </a:p>
+                  </a:txBody>
+                  <a:tcPr marL="63500" marR="63500" marT="38100" marB="38100">
+                    <a:noFill/>
+                  </a:tcPr>
+                </a:tc>
+                <a:tc>
+                  <a:txBody>
+                    <a:bodyPr wrap="square"/>
+                    <a:lstStyle/>
+                    <a:p>
+                      <a:r>
+                        <a:rPr sz="1100" b="0">
+                          <a:latin typeface="Calibri"/>
+                        </a:rPr>
+                        <a:t>The true shift in real data is unmeasured, so the reading cannot be graded</a:t>
+                      </a:r>
+                    </a:p>
+                  </a:txBody>
+                  <a:tcPr marL="63500" marR="63500" marT="38100" marB="38100">
+                    <a:noFill/>
+                  </a:tcPr>
+                </a:tc>
+              </a:tr>
+              <a:tr h="25400">
+                <a:tc>
+                  <a:txBody>
+                    <a:bodyPr wrap="square"/>
+                    <a:lstStyle/>
+                    <a:p>
+                      <a:r>
+                        <a:rPr sz="1100" b="0">
+                          <a:latin typeface="Calibri"/>
+                        </a:rPr>
+                        <a:t>Severity never moves the wrong way</a:t>
+                      </a:r>
+                    </a:p>
+                  </a:txBody>
+                  <a:tcPr marL="63500" marR="63500" marT="38100" marB="38100">
+                    <a:solidFill>
+                      <a:srgbClr val="F4F6F9"/>
+                    </a:solidFill>
+                  </a:tcPr>
+                </a:tc>
+                <a:tc>
+                  <a:txBody>
+                    <a:bodyPr wrap="square"/>
+                    <a:lstStyle/>
+                    <a:p>
+                      <a:r>
+                        <a:rPr sz="1100" b="0">
+                          <a:latin typeface="Calibri"/>
+                        </a:rPr>
+                        <a:t>500 randomised perturbations: increasing any feature's drift can never lower the reported severity</a:t>
+                      </a:r>
+                    </a:p>
+                  </a:txBody>
+                  <a:tcPr marL="63500" marR="63500" marT="38100" marB="38100">
+                    <a:solidFill>
+                      <a:srgbClr val="F4F6F9"/>
+                    </a:solidFill>
+                  </a:tcPr>
+                </a:tc>
+                <a:tc>
+                  <a:txBody>
+                    <a:bodyPr wrap="square"/>
+                    <a:lstStyle/>
+                    <a:p>
+                      <a:r>
+                        <a:rPr sz="1100" b="0">
+                          <a:latin typeface="Calibri"/>
+                        </a:rPr>
+                        <a:t>Requires controlling the input to know which direction is correct</a:t>
+                      </a:r>
+                    </a:p>
+                  </a:txBody>
+                  <a:tcPr marL="63500" marR="63500" marT="38100" marB="38100">
+                    <a:solidFill>
+                      <a:srgbClr val="F4F6F9"/>
+                    </a:solidFill>
+                  </a:tcPr>
+                </a:tc>
+              </a:tr>
+              <a:tr h="25400">
+                <a:tc>
+                  <a:txBody>
+                    <a:bodyPr wrap="square"/>
+                    <a:lstStyle/>
+                    <a:p>
+                      <a:r>
+                        <a:rPr sz="1100" b="0">
+                          <a:latin typeface="Calibri"/>
+                        </a:rPr>
+                        <a:t>It refuses to guess</a:t>
+                      </a:r>
+                    </a:p>
+                  </a:txBody>
+                  <a:tcPr marL="63500" marR="63500" marT="38100" marB="38100">
+                    <a:noFill/>
+                  </a:tcPr>
+                </a:tc>
+                <a:tc>
+                  <a:txBody>
+                    <a:bodyPr wrap="square"/>
+                    <a:lstStyle/>
+                    <a:p>
+                      <a:r>
+                        <a:rPr sz="1100" b="0">
+                          <a:latin typeface="Calibri"/>
+                        </a:rPr>
+                        <a:t>An empty window raises rather than returning 0.0; below MIN_SAMPLES = 30 it reports insufficient data</a:t>
+                      </a:r>
+                    </a:p>
+                  </a:txBody>
+                  <a:tcPr marL="63500" marR="63500" marT="38100" marB="38100">
+                    <a:noFill/>
+                  </a:tcPr>
+                </a:tc>
+                <a:tc>
+                  <a:txBody>
+                    <a:bodyPr wrap="square"/>
+                    <a:lstStyle/>
+                    <a:p>
+                      <a:r>
+                        <a:rPr sz="1100" b="0">
+                          <a:latin typeface="Calibri"/>
+                        </a:rPr>
+                        <a:t>Reporting 'no drift' for 'no data' is the exact failure the system exists to prevent</a:t>
+                      </a:r>
+                    </a:p>
+                  </a:txBody>
+                  <a:tcPr marL="63500" marR="63500" marT="38100" marB="38100">
+                    <a:noFill/>
+                  </a:tcPr>
+                </a:tc>
+              </a:tr>
+            </a:tbl>
+          </a:graphicData>
+        </a:graphic>
+      </p:graphicFrame>
+    </p:spTree>
+    <p:extLst>
+      <p:ext uri="{BB962C8B-B14F-4D97-AF65-F5344CB8AC3E}">
+        <p14:creationId xmlns:p14="http://schemas.microsoft.com/office/powerpoint/2010/main" val="3231882420"/>
+      </p:ext>
+    </p:extLst>
+  </p:cSld>
+  <p:clrMapOvr>
+    <a:masterClrMapping/>
+  </p:clrMapOvr>
+</p:sld>
+</file>
+
+<file path=ppt/slides/slide19.xml><?xml version="1.0" encoding="utf-8"?>
+<p:sld xmlns:a="http://schemas.openxmlformats.org/drawingml/2006/main" xmlns:r="http://schemas.openxmlformats.org/officeDocument/2006/relationships" xmlns:p="http://schemas.openxmlformats.org/presentationml/2006/main">
+  <p:cSld>
+    <p:spTree>
+      <p:nvGrpSpPr>
+        <p:cNvPr id="1" name=""/>
+        <p:cNvGrpSpPr/>
+        <p:nvPr/>
+      </p:nvGrpSpPr>
+      <p:grpSpPr>
+        <a:xfrm>
+          <a:off x="0" y="0"/>
+          <a:ext cx="0" cy="0"/>
+          <a:chOff x="0" y="0"/>
+          <a:chExt cx="0" cy="0"/>
+        </a:xfrm>
+      </p:grpSpPr>
+      <p:sp>
+        <p:nvSpPr>
+          <p:cNvPr id="2" name="Title 1">
+            <a:extLst>
+              <a:ext uri="{FF2B5EF4-FFF2-40B4-BE49-F238E27FC236}">
+                <a16:creationId xmlns:a16="http://schemas.microsoft.com/office/drawing/2014/main" id="{BD1A189D-22D1-4D1A-9E04-C6134EC51F8B}"/>
+              </a:ext>
+            </a:extLst>
+          </p:cNvPr>
+          <p:cNvSpPr>
+            <a:spLocks noGrp="1"/>
+          </p:cNvSpPr>
+          <p:nvPr>
+            <p:ph type="ctrTitle"/>
+          </p:nvPr>
+        </p:nvSpPr>
+        <p:spPr>
+          <a:xfrm>
+            <a:off x="1684868" y="203198"/>
+            <a:ext cx="9694332" cy="880535"/>
+          </a:xfrm>
+        </p:spPr>
+        <p:txBody>
+          <a:bodyPr>
+            <a:normAutofit/>
+          </a:bodyPr>
+          <a:lstStyle/>
+          <a:p>
+            <a:pPr marL="0" indent="0" algn="l">
+              <a:spcBef>
+                <a:spcPts val="0"/>
+              </a:spcBef>
+              <a:buNone/>
+            </a:pPr>
+            <a:r>
+              <a:rPr lang="en-US" sz="3200" b="1" i="0" dirty="0">
+                <a:latin typeface="Calibri" panose="020F0502020204030204" pitchFamily="34" charset="0"/>
+                <a:ea typeface="Calibri" panose="020F0502020204030204" pitchFamily="34" charset="0"/>
+                <a:cs typeface="Calibri" panose="020F0502020204030204" pitchFamily="34" charset="0"/>
+              </a:rPr>
+              <a:t>Validating the Latency Claim</a:t>
+            </a:r>
+          </a:p>
+        </p:txBody>
+      </p:sp>
+      <p:sp>
+        <p:nvSpPr>
+          <p:cNvPr id="3" name="Subtitle 2">
+            <a:extLst>
+              <a:ext uri="{FF2B5EF4-FFF2-40B4-BE49-F238E27FC236}">
+                <a16:creationId xmlns:a16="http://schemas.microsoft.com/office/drawing/2014/main" id="{255E737C-85F2-47BC-AD38-AD8B001473B7}"/>
+              </a:ext>
+            </a:extLst>
+          </p:cNvPr>
+          <p:cNvSpPr>
+            <a:spLocks noGrp="1"/>
+          </p:cNvSpPr>
+          <p:nvPr>
+            <p:ph type="subTitle" idx="1"/>
+          </p:nvPr>
+        </p:nvSpPr>
+        <p:spPr>
+          <a:xfrm>
+            <a:off x="1684867" y="1574800"/>
+            <a:ext cx="9694333" cy="4614333"/>
+          </a:xfrm>
+        </p:spPr>
+        <p:txBody>
+          <a:bodyPr>
+            <a:normAutofit/>
+          </a:bodyPr>
+          <a:lstStyle/>
+          <a:p>
+            <a:pPr marL="0" indent="0" algn="l">
+              <a:spcBef>
+                <a:spcPts val="0"/>
+              </a:spcBef>
+              <a:buNone/>
+            </a:pPr>
+            <a:r>
+              <a:rPr lang="en-US" sz="1400" b="0" i="0" dirty="0">
+                <a:latin typeface="Calibri" panose="020F0502020204030204" pitchFamily="34" charset="0"/>
+                <a:ea typeface="Calibri" panose="020F0502020204030204" pitchFamily="34" charset="0"/>
+                <a:cs typeface="Calibri" panose="020F0502020204030204" pitchFamily="34" charset="0"/>
+              </a:rPr>
+              <a:t>NFR1 asserts a 50 ms p99. An assertion in a design document is not evidence, so we built the instrument that could falsify it — and it did.</a:t>
+            </a:r>
+          </a:p>
+        </p:txBody>
+      </p:sp>
+      <p:pic>
+        <p:nvPicPr>
+          <p:cNvPr id="5" name="Graphic 4">
+            <a:extLst>
+              <a:ext uri="{FF2B5EF4-FFF2-40B4-BE49-F238E27FC236}">
+                <a16:creationId xmlns:a16="http://schemas.microsoft.com/office/drawing/2014/main" id="{E7125167-8301-4D88-B79A-A8DA3C19E0D6}"/>
+              </a:ext>
+            </a:extLst>
+          </p:cNvPr>
+          <p:cNvPicPr>
+            <a:picLocks noChangeAspect="1"/>
+          </p:cNvPicPr>
+          <p:nvPr/>
+        </p:nvPicPr>
+        <p:blipFill>
+          <a:blip r:embed="rId2">
+            <a:extLst>
+              <a:ext uri="{96DAC541-7B7A-43D3-8B79-37D633B846F1}">
+                <asvg:svgBlip xmlns:asvg="http://schemas.microsoft.com/office/drawing/2016/SVG/main" r:embed="rId3"/>
+              </a:ext>
+            </a:extLst>
+          </a:blip>
+          <a:stretch>
+            <a:fillRect/>
+          </a:stretch>
+        </p:blipFill>
+        <p:spPr>
+          <a:xfrm>
+            <a:off x="127001" y="86782"/>
+            <a:ext cx="1159932" cy="1159932"/>
+          </a:xfrm>
+          <a:prstGeom prst="rect">
+            <a:avLst/>
+          </a:prstGeom>
+        </p:spPr>
+      </p:pic>
+      <p:sp>
+        <p:nvSpPr>
+          <p:cNvPr id="4" name="Date Placeholder 3">
+            <a:extLst>
+              <a:ext uri="{FF2B5EF4-FFF2-40B4-BE49-F238E27FC236}">
+                <a16:creationId xmlns:a16="http://schemas.microsoft.com/office/drawing/2014/main" id="{35032362-C5A5-4DBF-AD79-DE6FB7439999}"/>
+              </a:ext>
+            </a:extLst>
+          </p:cNvPr>
+          <p:cNvSpPr>
+            <a:spLocks noGrp="1"/>
+          </p:cNvSpPr>
+          <p:nvPr>
+            <p:ph type="dt" sz="half" idx="10"/>
+          </p:nvPr>
+        </p:nvSpPr>
+        <p:spPr/>
+        <p:txBody>
+          <a:bodyPr/>
+          <a:lstStyle/>
+          <a:p>
+            <a:fld id="{64C96E34-94C0-49E4-A53B-4A44141FD3C8}" type="datetime3">
+              <a:rPr lang="en-US" smtClean="0"/>
+              <a:t>12 September 2026</a:t>
+            </a:fld>
+            <a:endParaRPr lang="en-US" dirty="0"/>
+          </a:p>
+        </p:txBody>
+      </p:sp>
+      <p:sp>
+        <p:nvSpPr>
+          <p:cNvPr id="6" name="Slide Number Placeholder 5">
+            <a:extLst>
+              <a:ext uri="{FF2B5EF4-FFF2-40B4-BE49-F238E27FC236}">
+                <a16:creationId xmlns:a16="http://schemas.microsoft.com/office/drawing/2014/main" id="{115AAB64-5B51-4B5A-B69E-D96362CE6E74}"/>
+              </a:ext>
+            </a:extLst>
+          </p:cNvPr>
+          <p:cNvSpPr>
+            <a:spLocks noGrp="1"/>
+          </p:cNvSpPr>
+          <p:nvPr>
+            <p:ph type="sldNum" sz="quarter" idx="12"/>
+          </p:nvPr>
+        </p:nvSpPr>
+        <p:spPr/>
+        <p:txBody>
+          <a:bodyPr/>
+          <a:lstStyle/>
+          <a:p>
+            <a:fld id="{D57F1E4F-1CFF-5643-939E-217C01CDF565}" type="slidenum">
+              <a:rPr lang="en-US" smtClean="0"/>
+              <a:pPr/>
+              <a:t>3</a:t>
+            </a:fld>
+            <a:endParaRPr lang="en-US" dirty="0"/>
+          </a:p>
+        </p:txBody>
+      </p:sp>
+      <p:sp>
+        <p:nvSpPr>
+          <p:cNvPr id="7" name="Footer Placeholder 6">
+            <a:extLst>
+              <a:ext uri="{FF2B5EF4-FFF2-40B4-BE49-F238E27FC236}">
+                <a16:creationId xmlns:a16="http://schemas.microsoft.com/office/drawing/2014/main" id="{8683C6DF-27D9-468B-A1AB-FE568488FE57}"/>
+              </a:ext>
+            </a:extLst>
+          </p:cNvPr>
+          <p:cNvSpPr>
+            <a:spLocks noGrp="1"/>
+          </p:cNvSpPr>
+          <p:nvPr>
+            <p:ph type="ftr" sz="quarter" idx="11"/>
+          </p:nvPr>
+        </p:nvSpPr>
+        <p:spPr/>
+        <p:txBody>
+          <a:bodyPr/>
+          <a:lstStyle/>
+          <a:p>
+            <a:r>
+              <a:rPr lang="en-US"/>
+              <a:t>Dept of AI &amp; DS</a:t>
+            </a:r>
+            <a:endParaRPr lang="en-US" dirty="0"/>
+          </a:p>
+        </p:txBody>
+      </p:sp>
+      <p:pic>
+        <p:nvPicPr>
+          <p:cNvPr id="8" name="Picture 7" descr="load_profile.png"/>
+          <p:cNvPicPr>
+            <a:picLocks noChangeAspect="1"/>
+          </p:cNvPicPr>
+          <p:nvPr/>
+        </p:nvPicPr>
+        <p:blipFill>
+          <a:blip r:embed="rId4"/>
+          <a:stretch>
+            <a:fillRect/>
+          </a:stretch>
+        </p:blipFill>
+        <p:spPr>
+          <a:xfrm>
+            <a:off x="1066647" y="2560320"/>
+            <a:ext cx="10058400" cy="3017520"/>
+          </a:xfrm>
+          <a:prstGeom prst="rect">
+            <a:avLst/>
+          </a:prstGeom>
+        </p:spPr>
+      </p:pic>
+    </p:spTree>
+    <p:extLst>
+      <p:ext uri="{BB962C8B-B14F-4D97-AF65-F5344CB8AC3E}">
+        <p14:creationId xmlns:p14="http://schemas.microsoft.com/office/powerpoint/2010/main" val="3231882420"/>
       </p:ext>
     </p:extLst>
   </p:cSld>
@@ -7274,6 +8429,40 @@
                 <a:ea typeface="Calibri" panose="020F0502020204030204" pitchFamily="34" charset="0"/>
                 <a:cs typeface="Calibri" panose="020F0502020204030204" pitchFamily="34" charset="0"/>
               </a:rPr>
+              <a:t>Data and validation — how the detector is calibrated, and against what</a:t>
+            </a:r>
+          </a:p>
+          <a:p>
+            <a:pPr marL="285750" indent="-285750" algn="l">
+              <a:spcBef>
+                <a:spcPts val="400"/>
+              </a:spcBef>
+              <a:buFont typeface="Arial" panose="020B0604020202020204" pitchFamily="34" charset="0"/>
+              <a:buChar char="•"/>
+            </a:pPr>
+            <a:r>
+              <a:rPr lang="en-US" sz="1800" b="0" i="0" dirty="0">
+                <a:latin typeface="Calibri" panose="020F0502020204030204" pitchFamily="34" charset="0"/>
+                <a:ea typeface="Calibri" panose="020F0502020204030204" pitchFamily="34" charset="0"/>
+                <a:cs typeface="Calibri" panose="020F0502020204030204" pitchFamily="34" charset="0"/>
+              </a:rPr>
+              <a:t>Engineering rigour — load testing, the defects it found, and the fixes</a:t>
+            </a:r>
+          </a:p>
+          <a:p>
+            <a:pPr marL="285750" indent="-285750" algn="l">
+              <a:spcBef>
+                <a:spcPts val="400"/>
+              </a:spcBef>
+              <a:buFont typeface="Arial" panose="020B0604020202020204" pitchFamily="34" charset="0"/>
+              <a:buChar char="•"/>
+            </a:pPr>
+            <a:r>
+              <a:rPr lang="en-US" sz="1800" b="0" i="0" dirty="0">
+                <a:latin typeface="Calibri" panose="020F0502020204030204" pitchFamily="34" charset="0"/>
+                <a:ea typeface="Calibri" panose="020F0502020204030204" pitchFamily="34" charset="0"/>
+                <a:cs typeface="Calibri" panose="020F0502020204030204" pitchFamily="34" charset="0"/>
+              </a:rPr>
               <a:t>Team contributions and conclusion</a:t>
             </a:r>
           </a:p>
@@ -7338,7 +8527,7 @@
           <a:p>
             <a:fld id="{1719FD98-5FDC-4CCE-BD5A-59D793565931}" type="datetime3">
               <a:rPr lang="en-US" smtClean="0"/>
-              <a:t>4 September 2026</a:t>
+              <a:t>12 September 2026</a:t>
             </a:fld>
             <a:endParaRPr lang="en-US" dirty="0"/>
           </a:p>
@@ -7407,6 +8596,1441 @@
     <p:extLst>
       <p:ext uri="{BB962C8B-B14F-4D97-AF65-F5344CB8AC3E}">
         <p14:creationId xmlns:p14="http://schemas.microsoft.com/office/powerpoint/2010/main" val="2366995734"/>
+      </p:ext>
+    </p:extLst>
+  </p:cSld>
+  <p:clrMapOvr>
+    <a:masterClrMapping/>
+  </p:clrMapOvr>
+</p:sld>
+</file>
+
+<file path=ppt/slides/slide20.xml><?xml version="1.0" encoding="utf-8"?>
+<p:sld xmlns:a="http://schemas.openxmlformats.org/drawingml/2006/main" xmlns:r="http://schemas.openxmlformats.org/officeDocument/2006/relationships" xmlns:p="http://schemas.openxmlformats.org/presentationml/2006/main">
+  <p:cSld>
+    <p:spTree>
+      <p:nvGrpSpPr>
+        <p:cNvPr id="1" name=""/>
+        <p:cNvGrpSpPr/>
+        <p:nvPr/>
+      </p:nvGrpSpPr>
+      <p:grpSpPr>
+        <a:xfrm>
+          <a:off x="0" y="0"/>
+          <a:ext cx="0" cy="0"/>
+          <a:chOff x="0" y="0"/>
+          <a:chExt cx="0" cy="0"/>
+        </a:xfrm>
+      </p:grpSpPr>
+      <p:sp>
+        <p:nvSpPr>
+          <p:cNvPr id="2" name="Title 1">
+            <a:extLst>
+              <a:ext uri="{FF2B5EF4-FFF2-40B4-BE49-F238E27FC236}">
+                <a16:creationId xmlns:a16="http://schemas.microsoft.com/office/drawing/2014/main" id="{BD1A189D-22D1-4D1A-9E04-C6134EC51F8B}"/>
+              </a:ext>
+            </a:extLst>
+          </p:cNvPr>
+          <p:cNvSpPr>
+            <a:spLocks noGrp="1"/>
+          </p:cNvSpPr>
+          <p:nvPr>
+            <p:ph type="ctrTitle"/>
+          </p:nvPr>
+        </p:nvSpPr>
+        <p:spPr>
+          <a:xfrm>
+            <a:off x="1684868" y="203198"/>
+            <a:ext cx="9694332" cy="880535"/>
+          </a:xfrm>
+        </p:spPr>
+        <p:txBody>
+          <a:bodyPr>
+            <a:normAutofit/>
+          </a:bodyPr>
+          <a:lstStyle/>
+          <a:p>
+            <a:pPr marL="0" indent="0" algn="l">
+              <a:spcBef>
+                <a:spcPts val="0"/>
+              </a:spcBef>
+              <a:buNone/>
+            </a:pPr>
+            <a:r>
+              <a:rPr lang="en-US" sz="3200" b="1" i="0" dirty="0">
+                <a:latin typeface="Calibri" panose="020F0502020204030204" pitchFamily="34" charset="0"/>
+                <a:ea typeface="Calibri" panose="020F0502020204030204" pitchFamily="34" charset="0"/>
+                <a:cs typeface="Calibri" panose="020F0502020204030204" pitchFamily="34" charset="0"/>
+              </a:rPr>
+              <a:t>What Load Testing Exposed</a:t>
+            </a:r>
+          </a:p>
+        </p:txBody>
+      </p:sp>
+      <p:sp>
+        <p:nvSpPr>
+          <p:cNvPr id="3" name="Subtitle 2">
+            <a:extLst>
+              <a:ext uri="{FF2B5EF4-FFF2-40B4-BE49-F238E27FC236}">
+                <a16:creationId xmlns:a16="http://schemas.microsoft.com/office/drawing/2014/main" id="{255E737C-85F2-47BC-AD38-AD8B001473B7}"/>
+              </a:ext>
+            </a:extLst>
+          </p:cNvPr>
+          <p:cNvSpPr>
+            <a:spLocks noGrp="1"/>
+          </p:cNvSpPr>
+          <p:nvPr>
+            <p:ph type="subTitle" idx="1"/>
+          </p:nvPr>
+        </p:nvSpPr>
+        <p:spPr>
+          <a:xfrm>
+            <a:off x="1684867" y="1574800"/>
+            <a:ext cx="9694333" cy="4614333"/>
+          </a:xfrm>
+        </p:spPr>
+        <p:txBody>
+          <a:bodyPr>
+            <a:normAutofit/>
+          </a:bodyPr>
+          <a:lstStyle/>
+          <a:p>
+            <a:pPr marL="0" indent="0" algn="l">
+              <a:spcBef>
+                <a:spcPts val="0"/>
+              </a:spcBef>
+              <a:buNone/>
+            </a:pPr>
+            <a:r>
+              <a:rPr lang="en-US" sz="1400" b="0" i="0" dirty="0">
+                <a:latin typeface="Calibri" panose="020F0502020204030204" pitchFamily="34" charset="0"/>
+                <a:ea typeface="Calibri" panose="020F0502020204030204" pitchFamily="34" charset="0"/>
+                <a:cs typeface="Calibri" panose="020F0502020204030204" pitchFamily="34" charset="0"/>
+              </a:rPr>
+              <a:t>Three defects, none of them reachable by a test that sends one request at a time. This is the difference between a suite that passes and a system that works.</a:t>
+            </a:r>
+          </a:p>
+        </p:txBody>
+      </p:sp>
+      <p:pic>
+        <p:nvPicPr>
+          <p:cNvPr id="5" name="Graphic 4">
+            <a:extLst>
+              <a:ext uri="{FF2B5EF4-FFF2-40B4-BE49-F238E27FC236}">
+                <a16:creationId xmlns:a16="http://schemas.microsoft.com/office/drawing/2014/main" id="{E7125167-8301-4D88-B79A-A8DA3C19E0D6}"/>
+              </a:ext>
+            </a:extLst>
+          </p:cNvPr>
+          <p:cNvPicPr>
+            <a:picLocks noChangeAspect="1"/>
+          </p:cNvPicPr>
+          <p:nvPr/>
+        </p:nvPicPr>
+        <p:blipFill>
+          <a:blip r:embed="rId2">
+            <a:extLst>
+              <a:ext uri="{96DAC541-7B7A-43D3-8B79-37D633B846F1}">
+                <asvg:svgBlip xmlns:asvg="http://schemas.microsoft.com/office/drawing/2016/SVG/main" r:embed="rId3"/>
+              </a:ext>
+            </a:extLst>
+          </a:blip>
+          <a:stretch>
+            <a:fillRect/>
+          </a:stretch>
+        </p:blipFill>
+        <p:spPr>
+          <a:xfrm>
+            <a:off x="127001" y="86782"/>
+            <a:ext cx="1159932" cy="1159932"/>
+          </a:xfrm>
+          <a:prstGeom prst="rect">
+            <a:avLst/>
+          </a:prstGeom>
+        </p:spPr>
+      </p:pic>
+      <p:sp>
+        <p:nvSpPr>
+          <p:cNvPr id="4" name="Date Placeholder 3">
+            <a:extLst>
+              <a:ext uri="{FF2B5EF4-FFF2-40B4-BE49-F238E27FC236}">
+                <a16:creationId xmlns:a16="http://schemas.microsoft.com/office/drawing/2014/main" id="{35032362-C5A5-4DBF-AD79-DE6FB7439999}"/>
+              </a:ext>
+            </a:extLst>
+          </p:cNvPr>
+          <p:cNvSpPr>
+            <a:spLocks noGrp="1"/>
+          </p:cNvSpPr>
+          <p:nvPr>
+            <p:ph type="dt" sz="half" idx="10"/>
+          </p:nvPr>
+        </p:nvSpPr>
+        <p:spPr/>
+        <p:txBody>
+          <a:bodyPr/>
+          <a:lstStyle/>
+          <a:p>
+            <a:fld id="{64C96E34-94C0-49E4-A53B-4A44141FD3C8}" type="datetime3">
+              <a:rPr lang="en-US" smtClean="0"/>
+              <a:t>12 September 2026</a:t>
+            </a:fld>
+            <a:endParaRPr lang="en-US" dirty="0"/>
+          </a:p>
+        </p:txBody>
+      </p:sp>
+      <p:sp>
+        <p:nvSpPr>
+          <p:cNvPr id="6" name="Slide Number Placeholder 5">
+            <a:extLst>
+              <a:ext uri="{FF2B5EF4-FFF2-40B4-BE49-F238E27FC236}">
+                <a16:creationId xmlns:a16="http://schemas.microsoft.com/office/drawing/2014/main" id="{115AAB64-5B51-4B5A-B69E-D96362CE6E74}"/>
+              </a:ext>
+            </a:extLst>
+          </p:cNvPr>
+          <p:cNvSpPr>
+            <a:spLocks noGrp="1"/>
+          </p:cNvSpPr>
+          <p:nvPr>
+            <p:ph type="sldNum" sz="quarter" idx="12"/>
+          </p:nvPr>
+        </p:nvSpPr>
+        <p:spPr/>
+        <p:txBody>
+          <a:bodyPr/>
+          <a:lstStyle/>
+          <a:p>
+            <a:fld id="{D57F1E4F-1CFF-5643-939E-217C01CDF565}" type="slidenum">
+              <a:rPr lang="en-US" smtClean="0"/>
+              <a:pPr/>
+              <a:t>3</a:t>
+            </a:fld>
+            <a:endParaRPr lang="en-US" dirty="0"/>
+          </a:p>
+        </p:txBody>
+      </p:sp>
+      <p:sp>
+        <p:nvSpPr>
+          <p:cNvPr id="7" name="Footer Placeholder 6">
+            <a:extLst>
+              <a:ext uri="{FF2B5EF4-FFF2-40B4-BE49-F238E27FC236}">
+                <a16:creationId xmlns:a16="http://schemas.microsoft.com/office/drawing/2014/main" id="{8683C6DF-27D9-468B-A1AB-FE568488FE57}"/>
+              </a:ext>
+            </a:extLst>
+          </p:cNvPr>
+          <p:cNvSpPr>
+            <a:spLocks noGrp="1"/>
+          </p:cNvSpPr>
+          <p:nvPr>
+            <p:ph type="ftr" sz="quarter" idx="11"/>
+          </p:nvPr>
+        </p:nvSpPr>
+        <p:spPr/>
+        <p:txBody>
+          <a:bodyPr/>
+          <a:lstStyle/>
+          <a:p>
+            <a:r>
+              <a:rPr lang="en-US"/>
+              <a:t>Dept of AI &amp; DS</a:t>
+            </a:r>
+            <a:endParaRPr lang="en-US" dirty="0"/>
+          </a:p>
+        </p:txBody>
+      </p:sp>
+      <p:graphicFrame>
+        <p:nvGraphicFramePr>
+          <p:cNvPr id="8" name="Table 7"/>
+          <p:cNvGraphicFramePr>
+            <a:graphicFrameLocks noGrp="1"/>
+          </p:cNvGraphicFramePr>
+          <p:nvPr/>
+        </p:nvGraphicFramePr>
+        <p:xfrm>
+          <a:off x="960120" y="2468880"/>
+          <a:ext cx="10241279" cy="101600"/>
+        </p:xfrm>
+        <a:graphic>
+          <a:graphicData uri="http://schemas.openxmlformats.org/drawingml/2006/table">
+            <a:tbl>
+              <a:tblPr firstRow="1">
+                <a:tableStyleId>{5C22544A-7EE6-4342-B048-85BDC9FD1C3A}</a:tableStyleId>
+              </a:tblPr>
+              <a:tblGrid>
+                <a:gridCol w="2048256"/>
+                <a:gridCol w="4915814"/>
+                <a:gridCol w="3277209"/>
+              </a:tblGrid>
+              <a:tr h="25400">
+                <a:tc>
+                  <a:txBody>
+                    <a:bodyPr wrap="square"/>
+                    <a:lstStyle/>
+                    <a:p>
+                      <a:r>
+                        <a:rPr sz="1100" b="1">
+                          <a:solidFill>
+                            <a:srgbClr val="FFFFFF"/>
+                          </a:solidFill>
+                          <a:latin typeface="Calibri"/>
+                        </a:rPr>
+                        <a:t>What we believed</a:t>
+                      </a:r>
+                    </a:p>
+                  </a:txBody>
+                  <a:tcPr marL="63500" marR="63500" marT="38100" marB="38100">
+                    <a:solidFill>
+                      <a:srgbClr val="1F5CA8"/>
+                    </a:solidFill>
+                  </a:tcPr>
+                </a:tc>
+                <a:tc>
+                  <a:txBody>
+                    <a:bodyPr wrap="square"/>
+                    <a:lstStyle/>
+                    <a:p>
+                      <a:r>
+                        <a:rPr sz="1100" b="1">
+                          <a:solidFill>
+                            <a:srgbClr val="FFFFFF"/>
+                          </a:solidFill>
+                          <a:latin typeface="Calibri"/>
+                        </a:rPr>
+                        <a:t>What the harness measured</a:t>
+                      </a:r>
+                    </a:p>
+                  </a:txBody>
+                  <a:tcPr marL="63500" marR="63500" marT="38100" marB="38100">
+                    <a:solidFill>
+                      <a:srgbClr val="1F5CA8"/>
+                    </a:solidFill>
+                  </a:tcPr>
+                </a:tc>
+                <a:tc>
+                  <a:txBody>
+                    <a:bodyPr wrap="square"/>
+                    <a:lstStyle/>
+                    <a:p>
+                      <a:r>
+                        <a:rPr sz="1100" b="1">
+                          <a:solidFill>
+                            <a:srgbClr val="FFFFFF"/>
+                          </a:solidFill>
+                          <a:latin typeface="Calibri"/>
+                        </a:rPr>
+                        <a:t>What we did</a:t>
+                      </a:r>
+                    </a:p>
+                  </a:txBody>
+                  <a:tcPr marL="63500" marR="63500" marT="38100" marB="38100">
+                    <a:solidFill>
+                      <a:srgbClr val="1F5CA8"/>
+                    </a:solidFill>
+                  </a:tcPr>
+                </a:tc>
+              </a:tr>
+              <a:tr h="25400">
+                <a:tc>
+                  <a:txBody>
+                    <a:bodyPr wrap="square"/>
+                    <a:lstStyle/>
+                    <a:p>
+                      <a:r>
+                        <a:rPr sz="1100" b="0">
+                          <a:latin typeface="Calibri"/>
+                        </a:rPr>
+                        <a:t>Gateway p99 is 0.5 ms</a:t>
+                      </a:r>
+                    </a:p>
+                  </a:txBody>
+                  <a:tcPr marL="63500" marR="63500" marT="38100" marB="38100">
+                    <a:noFill/>
+                  </a:tcPr>
+                </a:tc>
+                <a:tc>
+                  <a:txBody>
+                    <a:bodyPr wrap="square"/>
+                    <a:lstStyle/>
+                    <a:p>
+                      <a:r>
+                        <a:rPr sz="1100" b="0">
+                          <a:latin typeface="Calibri"/>
+                        </a:rPr>
+                        <a:t>0.5 ms was the trust engine's own timer, which stops before the audit write. The caller actually waits 49 ms at the ceiling — 98% of the budget, not 1%</a:t>
+                      </a:r>
+                    </a:p>
+                  </a:txBody>
+                  <a:tcPr marL="63500" marR="63500" marT="38100" marB="38100">
+                    <a:noFill/>
+                  </a:tcPr>
+                </a:tc>
+                <a:tc>
+                  <a:txBody>
+                    <a:bodyPr wrap="square"/>
+                    <a:lstStyle/>
+                    <a:p>
+                      <a:r>
+                        <a:rPr sz="1100" b="0">
+                          <a:latin typeface="Calibri"/>
+                        </a:rPr>
+                        <a:t>Report the client-observed number; treat the internal metric as a component timing, not the request</a:t>
+                      </a:r>
+                    </a:p>
+                  </a:txBody>
+                  <a:tcPr marL="63500" marR="63500" marT="38100" marB="38100">
+                    <a:noFill/>
+                  </a:tcPr>
+                </a:tc>
+              </a:tr>
+              <a:tr h="25400">
+                <a:tc>
+                  <a:txBody>
+                    <a:bodyPr wrap="square"/>
+                    <a:lstStyle/>
+                    <a:p>
+                      <a:r>
+                        <a:rPr sz="1100" b="0">
+                          <a:latin typeface="Calibri"/>
+                        </a:rPr>
+                        <a:t>The audit chain records every decision</a:t>
+                      </a:r>
+                    </a:p>
+                  </a:txBody>
+                  <a:tcPr marL="63500" marR="63500" marT="38100" marB="38100">
+                    <a:solidFill>
+                      <a:srgbClr val="F4F6F9"/>
+                    </a:solidFill>
+                  </a:tcPr>
+                </a:tc>
+                <a:tc>
+                  <a:txBody>
+                    <a:bodyPr wrap="square"/>
+                    <a:lstStyle/>
+                    <a:p>
+                      <a:r>
+                        <a:rPr sz="1100" b="0">
+                          <a:latin typeface="Calibri"/>
+                        </a:rPr>
+                        <a:t>Under concurrent appends, 2 of 96 entries were dropped — and verification still reported the chain intact, because a hash chain detects a modified entry, never a missing one</a:t>
+                      </a:r>
+                    </a:p>
+                  </a:txBody>
+                  <a:tcPr marL="63500" marR="63500" marT="38100" marB="38100">
+                    <a:solidFill>
+                      <a:srgbClr val="F4F6F9"/>
+                    </a:solidFill>
+                  </a:tcPr>
+                </a:tc>
+                <a:tc>
+                  <a:txBody>
+                    <a:bodyPr wrap="square"/>
+                    <a:lstStyle/>
+                    <a:p>
+                      <a:r>
+                        <a:rPr sz="1100" b="0">
+                          <a:latin typeface="Calibri"/>
+                        </a:rPr>
+                        <a:t>Per-tenant advisory lock on Postgres, jittered backoff everywhere. 0 lost from 2 to 48 writers</a:t>
+                      </a:r>
+                    </a:p>
+                  </a:txBody>
+                  <a:tcPr marL="63500" marR="63500" marT="38100" marB="38100">
+                    <a:solidFill>
+                      <a:srgbClr val="F4F6F9"/>
+                    </a:solidFill>
+                  </a:tcPr>
+                </a:tc>
+              </a:tr>
+              <a:tr h="25400">
+                <a:tc>
+                  <a:txBody>
+                    <a:bodyPr wrap="square"/>
+                    <a:lstStyle/>
+                    <a:p>
+                      <a:r>
+                        <a:rPr sz="1100" b="0">
+                          <a:latin typeface="Calibri"/>
+                        </a:rPr>
+                        <a:t>Overload makes it slow</a:t>
+                      </a:r>
+                    </a:p>
+                  </a:txBody>
+                  <a:tcPr marL="63500" marR="63500" marT="38100" marB="38100">
+                    <a:noFill/>
+                  </a:tcPr>
+                </a:tc>
+                <a:tc>
+                  <a:txBody>
+                    <a:bodyPr wrap="square"/>
+                    <a:lstStyle/>
+                    <a:p>
+                      <a:r>
+                        <a:rPr sz="1100" b="0">
+                          <a:latin typeface="Calibri"/>
+                        </a:rPr>
+                        <a:t>Overload makes it answer differently: past the ceiling, engines exceed their 20 ms timeout, drop out of fusion, and ~13% of verdicts flip ALLOW to REVIEW on traffic an idle gateway allows</a:t>
+                      </a:r>
+                    </a:p>
+                  </a:txBody>
+                  <a:tcPr marL="63500" marR="63500" marT="38100" marB="38100">
+                    <a:noFill/>
+                  </a:tcPr>
+                </a:tc>
+                <a:tc>
+                  <a:txBody>
+                    <a:bodyPr wrap="square"/>
+                    <a:lstStyle/>
+                    <a:p>
+                      <a:r>
+                        <a:rPr sz="1100" b="0">
+                          <a:latin typeface="Calibri"/>
+                        </a:rPr>
+                        <a:t>Documented as an operational property; admission control is the Review-2 fix</a:t>
+                      </a:r>
+                    </a:p>
+                  </a:txBody>
+                  <a:tcPr marL="63500" marR="63500" marT="38100" marB="38100">
+                    <a:noFill/>
+                  </a:tcPr>
+                </a:tc>
+              </a:tr>
+            </a:tbl>
+          </a:graphicData>
+        </a:graphic>
+      </p:graphicFrame>
+    </p:spTree>
+    <p:extLst>
+      <p:ext uri="{BB962C8B-B14F-4D97-AF65-F5344CB8AC3E}">
+        <p14:creationId xmlns:p14="http://schemas.microsoft.com/office/powerpoint/2010/main" val="3231882420"/>
+      </p:ext>
+    </p:extLst>
+  </p:cSld>
+  <p:clrMapOvr>
+    <a:masterClrMapping/>
+  </p:clrMapOvr>
+</p:sld>
+</file>
+
+<file path=ppt/slides/slide21.xml><?xml version="1.0" encoding="utf-8"?>
+<p:sld xmlns:a="http://schemas.openxmlformats.org/drawingml/2006/main" xmlns:r="http://schemas.openxmlformats.org/officeDocument/2006/relationships" xmlns:p="http://schemas.openxmlformats.org/presentationml/2006/main">
+  <p:cSld>
+    <p:spTree>
+      <p:nvGrpSpPr>
+        <p:cNvPr id="1" name=""/>
+        <p:cNvGrpSpPr/>
+        <p:nvPr/>
+      </p:nvGrpSpPr>
+      <p:grpSpPr>
+        <a:xfrm>
+          <a:off x="0" y="0"/>
+          <a:ext cx="0" cy="0"/>
+          <a:chOff x="0" y="0"/>
+          <a:chExt cx="0" cy="0"/>
+        </a:xfrm>
+      </p:grpSpPr>
+      <p:sp>
+        <p:nvSpPr>
+          <p:cNvPr id="2" name="Title 1">
+            <a:extLst>
+              <a:ext uri="{FF2B5EF4-FFF2-40B4-BE49-F238E27FC236}">
+                <a16:creationId xmlns:a16="http://schemas.microsoft.com/office/drawing/2014/main" id="{BD1A189D-22D1-4D1A-9E04-C6134EC51F8B}"/>
+              </a:ext>
+            </a:extLst>
+          </p:cNvPr>
+          <p:cNvSpPr>
+            <a:spLocks noGrp="1"/>
+          </p:cNvSpPr>
+          <p:nvPr>
+            <p:ph type="ctrTitle"/>
+          </p:nvPr>
+        </p:nvSpPr>
+        <p:spPr>
+          <a:xfrm>
+            <a:off x="1684868" y="203198"/>
+            <a:ext cx="9694332" cy="880535"/>
+          </a:xfrm>
+        </p:spPr>
+        <p:txBody>
+          <a:bodyPr>
+            <a:normAutofit/>
+          </a:bodyPr>
+          <a:lstStyle/>
+          <a:p>
+            <a:pPr marL="0" indent="0" algn="l">
+              <a:spcBef>
+                <a:spcPts val="0"/>
+              </a:spcBef>
+              <a:buNone/>
+            </a:pPr>
+            <a:r>
+              <a:rPr lang="en-US" sz="3200" b="1" i="0" dirty="0">
+                <a:latin typeface="Calibri" panose="020F0502020204030204" pitchFamily="34" charset="0"/>
+                <a:ea typeface="Calibri" panose="020F0502020204030204" pitchFamily="34" charset="0"/>
+                <a:cs typeface="Calibri" panose="020F0502020204030204" pitchFamily="34" charset="0"/>
+              </a:rPr>
+              <a:t>Case Study — The Audit Log That Lied</a:t>
+            </a:r>
+          </a:p>
+        </p:txBody>
+      </p:sp>
+      <p:sp>
+        <p:nvSpPr>
+          <p:cNvPr id="3" name="Subtitle 2">
+            <a:extLst>
+              <a:ext uri="{FF2B5EF4-FFF2-40B4-BE49-F238E27FC236}">
+                <a16:creationId xmlns:a16="http://schemas.microsoft.com/office/drawing/2014/main" id="{255E737C-85F2-47BC-AD38-AD8B001473B7}"/>
+              </a:ext>
+            </a:extLst>
+          </p:cNvPr>
+          <p:cNvSpPr>
+            <a:spLocks noGrp="1"/>
+          </p:cNvSpPr>
+          <p:nvPr>
+            <p:ph type="subTitle" idx="1"/>
+          </p:nvPr>
+        </p:nvSpPr>
+        <p:spPr>
+          <a:xfrm>
+            <a:off x="1684867" y="1574800"/>
+            <a:ext cx="9694333" cy="4614333"/>
+          </a:xfrm>
+        </p:spPr>
+        <p:txBody>
+          <a:bodyPr>
+            <a:normAutofit/>
+          </a:bodyPr>
+          <a:lstStyle/>
+          <a:p>
+            <a:pPr marL="0" indent="0" algn="l">
+              <a:spcBef>
+                <a:spcPts val="0"/>
+              </a:spcBef>
+              <a:buNone/>
+            </a:pPr>
+            <a:r>
+              <a:rPr lang="en-US" sz="1400" b="0" i="0" dirty="0">
+                <a:latin typeface="Calibri" panose="020F0502020204030204" pitchFamily="34" charset="0"/>
+                <a:ea typeface="Calibri" panose="020F0502020204030204" pitchFamily="34" charset="0"/>
+                <a:cs typeface="Calibri" panose="020F0502020204030204" pitchFamily="34" charset="0"/>
+              </a:rPr>
+              <a:t>Our strongest claim is tamper-evident evidence for every decision. Under concurrency it was dropping entries and reporting itself intact.</a:t>
+            </a:r>
+          </a:p>
+          <a:p>
+            <a:pPr marL="0" indent="0" algn="l">
+              <a:spcBef>
+                <a:spcPts val="280"/>
+              </a:spcBef>
+              <a:buNone/>
+            </a:pPr>
+            <a:r>
+              <a:rPr lang="en-US" sz="1500" b="1" i="0" dirty="0">
+                <a:latin typeface="Calibri" panose="020F0502020204030204" pitchFamily="34" charset="0"/>
+                <a:ea typeface="Calibri" panose="020F0502020204030204" pitchFamily="34" charset="0"/>
+                <a:cs typeface="Calibri" panose="020F0502020204030204" pitchFamily="34" charset="0"/>
+              </a:rPr>
+              <a:t>Symptom</a:t>
+            </a:r>
+          </a:p>
+          <a:p>
+            <a:pPr marL="285750" indent="-285750" algn="l">
+              <a:spcBef>
+                <a:spcPts val="400"/>
+              </a:spcBef>
+              <a:buFont typeface="Arial" panose="020B0604020202020204" pitchFamily="34" charset="0"/>
+              <a:buChar char="•"/>
+            </a:pPr>
+            <a:r>
+              <a:rPr lang="en-US" sz="1300" b="0" i="0" dirty="0">
+                <a:latin typeface="Calibri" panose="020F0502020204030204" pitchFamily="34" charset="0"/>
+                <a:ea typeface="Calibri" panose="020F0502020204030204" pitchFamily="34" charset="0"/>
+                <a:cs typeface="Calibri" panose="020F0502020204030204" pitchFamily="34" charset="0"/>
+              </a:rPr>
+              <a:t>At 24 concurrent writers, 2 of 96 appends were lost — and GET /audit/verify still returned “all 94 entries verified”. A hash chain detects a modified entry, never a missing one.</a:t>
+            </a:r>
+          </a:p>
+          <a:p>
+            <a:pPr marL="0" indent="0" algn="l">
+              <a:spcBef>
+                <a:spcPts val="200"/>
+              </a:spcBef>
+              <a:buNone/>
+            </a:pPr>
+            <a:r>
+              <a:rPr lang="en-US" sz="1500" b="1" i="0" dirty="0">
+                <a:latin typeface="Calibri" panose="020F0502020204030204" pitchFamily="34" charset="0"/>
+                <a:ea typeface="Calibri" panose="020F0502020204030204" pitchFamily="34" charset="0"/>
+                <a:cs typeface="Calibri" panose="020F0502020204030204" pitchFamily="34" charset="0"/>
+              </a:rPr>
+              <a:t>Diagnosis before cure</a:t>
+            </a:r>
+          </a:p>
+          <a:p>
+            <a:pPr marL="285750" indent="-285750" algn="l">
+              <a:spcBef>
+                <a:spcPts val="400"/>
+              </a:spcBef>
+              <a:buFont typeface="Arial" panose="020B0604020202020204" pitchFamily="34" charset="0"/>
+              <a:buChar char="•"/>
+            </a:pPr>
+            <a:r>
+              <a:rPr lang="en-US" sz="1300" b="0" i="0" dirty="0">
+                <a:latin typeface="Calibri" panose="020F0502020204030204" pitchFamily="34" charset="0"/>
+                <a:ea typeface="Calibri" panose="020F0502020204030204" pitchFamily="34" charset="0"/>
+                <a:cs typeface="Calibri" panose="020F0502020204030204" pitchFamily="34" charset="0"/>
+              </a:rPr>
+              <a:t>Measured where it was actually reachable: 0 lost at 1 uvicorn worker, 2 lost at 4. The event loop already serialised single-worker writes, so the obvious per-tenant in-process lock would have protected the only configuration that was not broken.</a:t>
+            </a:r>
+          </a:p>
+          <a:p>
+            <a:pPr marL="0" indent="0" algn="l">
+              <a:spcBef>
+                <a:spcPts val="200"/>
+              </a:spcBef>
+              <a:buNone/>
+            </a:pPr>
+            <a:r>
+              <a:rPr lang="en-US" sz="1500" b="1" i="0" dirty="0">
+                <a:latin typeface="Calibri" panose="020F0502020204030204" pitchFamily="34" charset="0"/>
+                <a:ea typeface="Calibri" panose="020F0502020204030204" pitchFamily="34" charset="0"/>
+                <a:cs typeface="Calibri" panose="020F0502020204030204" pitchFamily="34" charset="0"/>
+              </a:rPr>
+              <a:t>Fix</a:t>
+            </a:r>
+          </a:p>
+          <a:p>
+            <a:pPr marL="285750" indent="-285750" algn="l">
+              <a:spcBef>
+                <a:spcPts val="400"/>
+              </a:spcBef>
+              <a:buFont typeface="Arial" panose="020B0604020202020204" pitchFamily="34" charset="0"/>
+              <a:buChar char="•"/>
+            </a:pPr>
+            <a:r>
+              <a:rPr lang="en-US" sz="1300" b="0" i="0" dirty="0">
+                <a:latin typeface="Calibri" panose="020F0502020204030204" pitchFamily="34" charset="0"/>
+                <a:ea typeface="Calibri" panose="020F0502020204030204" pitchFamily="34" charset="0"/>
+                <a:cs typeface="Calibri" panose="020F0502020204030204" pitchFamily="34" charset="0"/>
+              </a:rPr>
+              <a:t>Postgres: pg_advisory_xact_lock per tenant, taken before the chain head is read. Every backend: jittered backoff, because five instant retries kept the racers in lockstep. Result: 0 lost from 2 to 48 writers — and 2× the throughput, since the retry storm was itself the load.</a:t>
+            </a:r>
+          </a:p>
+        </p:txBody>
+      </p:sp>
+      <p:pic>
+        <p:nvPicPr>
+          <p:cNvPr id="5" name="Graphic 4">
+            <a:extLst>
+              <a:ext uri="{FF2B5EF4-FFF2-40B4-BE49-F238E27FC236}">
+                <a16:creationId xmlns:a16="http://schemas.microsoft.com/office/drawing/2014/main" id="{E7125167-8301-4D88-B79A-A8DA3C19E0D6}"/>
+              </a:ext>
+            </a:extLst>
+          </p:cNvPr>
+          <p:cNvPicPr>
+            <a:picLocks noChangeAspect="1"/>
+          </p:cNvPicPr>
+          <p:nvPr/>
+        </p:nvPicPr>
+        <p:blipFill>
+          <a:blip r:embed="rId2">
+            <a:extLst>
+              <a:ext uri="{96DAC541-7B7A-43D3-8B79-37D633B846F1}">
+                <asvg:svgBlip xmlns:asvg="http://schemas.microsoft.com/office/drawing/2016/SVG/main" r:embed="rId3"/>
+              </a:ext>
+            </a:extLst>
+          </a:blip>
+          <a:stretch>
+            <a:fillRect/>
+          </a:stretch>
+        </p:blipFill>
+        <p:spPr>
+          <a:xfrm>
+            <a:off x="127001" y="86782"/>
+            <a:ext cx="1159932" cy="1159932"/>
+          </a:xfrm>
+          <a:prstGeom prst="rect">
+            <a:avLst/>
+          </a:prstGeom>
+        </p:spPr>
+      </p:pic>
+      <p:sp>
+        <p:nvSpPr>
+          <p:cNvPr id="4" name="Date Placeholder 3">
+            <a:extLst>
+              <a:ext uri="{FF2B5EF4-FFF2-40B4-BE49-F238E27FC236}">
+                <a16:creationId xmlns:a16="http://schemas.microsoft.com/office/drawing/2014/main" id="{35032362-C5A5-4DBF-AD79-DE6FB7439999}"/>
+              </a:ext>
+            </a:extLst>
+          </p:cNvPr>
+          <p:cNvSpPr>
+            <a:spLocks noGrp="1"/>
+          </p:cNvSpPr>
+          <p:nvPr>
+            <p:ph type="dt" sz="half" idx="10"/>
+          </p:nvPr>
+        </p:nvSpPr>
+        <p:spPr/>
+        <p:txBody>
+          <a:bodyPr/>
+          <a:lstStyle/>
+          <a:p>
+            <a:fld id="{64C96E34-94C0-49E4-A53B-4A44141FD3C8}" type="datetime3">
+              <a:rPr lang="en-US" smtClean="0"/>
+              <a:t>12 September 2026</a:t>
+            </a:fld>
+            <a:endParaRPr lang="en-US" dirty="0"/>
+          </a:p>
+        </p:txBody>
+      </p:sp>
+      <p:sp>
+        <p:nvSpPr>
+          <p:cNvPr id="6" name="Slide Number Placeholder 5">
+            <a:extLst>
+              <a:ext uri="{FF2B5EF4-FFF2-40B4-BE49-F238E27FC236}">
+                <a16:creationId xmlns:a16="http://schemas.microsoft.com/office/drawing/2014/main" id="{115AAB64-5B51-4B5A-B69E-D96362CE6E74}"/>
+              </a:ext>
+            </a:extLst>
+          </p:cNvPr>
+          <p:cNvSpPr>
+            <a:spLocks noGrp="1"/>
+          </p:cNvSpPr>
+          <p:nvPr>
+            <p:ph type="sldNum" sz="quarter" idx="12"/>
+          </p:nvPr>
+        </p:nvSpPr>
+        <p:spPr/>
+        <p:txBody>
+          <a:bodyPr/>
+          <a:lstStyle/>
+          <a:p>
+            <a:fld id="{D57F1E4F-1CFF-5643-939E-217C01CDF565}" type="slidenum">
+              <a:rPr lang="en-US" smtClean="0"/>
+              <a:pPr/>
+              <a:t>3</a:t>
+            </a:fld>
+            <a:endParaRPr lang="en-US" dirty="0"/>
+          </a:p>
+        </p:txBody>
+      </p:sp>
+      <p:sp>
+        <p:nvSpPr>
+          <p:cNvPr id="7" name="Footer Placeholder 6">
+            <a:extLst>
+              <a:ext uri="{FF2B5EF4-FFF2-40B4-BE49-F238E27FC236}">
+                <a16:creationId xmlns:a16="http://schemas.microsoft.com/office/drawing/2014/main" id="{8683C6DF-27D9-468B-A1AB-FE568488FE57}"/>
+              </a:ext>
+            </a:extLst>
+          </p:cNvPr>
+          <p:cNvSpPr>
+            <a:spLocks noGrp="1"/>
+          </p:cNvSpPr>
+          <p:nvPr>
+            <p:ph type="ftr" sz="quarter" idx="11"/>
+          </p:nvPr>
+        </p:nvSpPr>
+        <p:spPr/>
+        <p:txBody>
+          <a:bodyPr/>
+          <a:lstStyle/>
+          <a:p>
+            <a:r>
+              <a:rPr lang="en-US"/>
+              <a:t>Dept of AI &amp; DS</a:t>
+            </a:r>
+            <a:endParaRPr lang="en-US" dirty="0"/>
+          </a:p>
+        </p:txBody>
+      </p:sp>
+    </p:spTree>
+    <p:extLst>
+      <p:ext uri="{BB962C8B-B14F-4D97-AF65-F5344CB8AC3E}">
+        <p14:creationId xmlns:p14="http://schemas.microsoft.com/office/powerpoint/2010/main" val="3231882420"/>
+      </p:ext>
+    </p:extLst>
+  </p:cSld>
+  <p:clrMapOvr>
+    <a:masterClrMapping/>
+  </p:clrMapOvr>
+</p:sld>
+</file>
+
+<file path=ppt/slides/slide22.xml><?xml version="1.0" encoding="utf-8"?>
+<p:sld xmlns:a="http://schemas.openxmlformats.org/drawingml/2006/main" xmlns:r="http://schemas.openxmlformats.org/officeDocument/2006/relationships" xmlns:p="http://schemas.openxmlformats.org/presentationml/2006/main">
+  <p:cSld>
+    <p:spTree>
+      <p:nvGrpSpPr>
+        <p:cNvPr id="1" name=""/>
+        <p:cNvGrpSpPr/>
+        <p:nvPr/>
+      </p:nvGrpSpPr>
+      <p:grpSpPr>
+        <a:xfrm>
+          <a:off x="0" y="0"/>
+          <a:ext cx="0" cy="0"/>
+          <a:chOff x="0" y="0"/>
+          <a:chExt cx="0" cy="0"/>
+        </a:xfrm>
+      </p:grpSpPr>
+      <p:sp>
+        <p:nvSpPr>
+          <p:cNvPr id="2" name="Title 1">
+            <a:extLst>
+              <a:ext uri="{FF2B5EF4-FFF2-40B4-BE49-F238E27FC236}">
+                <a16:creationId xmlns:a16="http://schemas.microsoft.com/office/drawing/2014/main" id="{BD1A189D-22D1-4D1A-9E04-C6134EC51F8B}"/>
+              </a:ext>
+            </a:extLst>
+          </p:cNvPr>
+          <p:cNvSpPr>
+            <a:spLocks noGrp="1"/>
+          </p:cNvSpPr>
+          <p:nvPr>
+            <p:ph type="ctrTitle"/>
+          </p:nvPr>
+        </p:nvSpPr>
+        <p:spPr>
+          <a:xfrm>
+            <a:off x="1684868" y="203198"/>
+            <a:ext cx="9694332" cy="880535"/>
+          </a:xfrm>
+        </p:spPr>
+        <p:txBody>
+          <a:bodyPr>
+            <a:normAutofit/>
+          </a:bodyPr>
+          <a:lstStyle/>
+          <a:p>
+            <a:pPr marL="0" indent="0" algn="l">
+              <a:spcBef>
+                <a:spcPts val="0"/>
+              </a:spcBef>
+              <a:buNone/>
+            </a:pPr>
+            <a:r>
+              <a:rPr lang="en-US" sz="3200" b="1" i="0" dirty="0">
+                <a:latin typeface="Calibri" panose="020F0502020204030204" pitchFamily="34" charset="0"/>
+                <a:ea typeface="Calibri" panose="020F0502020204030204" pitchFamily="34" charset="0"/>
+                <a:cs typeface="Calibri" panose="020F0502020204030204" pitchFamily="34" charset="0"/>
+              </a:rPr>
+              <a:t>Contributions and Conclusion</a:t>
+            </a:r>
+          </a:p>
+        </p:txBody>
+      </p:sp>
+      <p:sp>
+        <p:nvSpPr>
+          <p:cNvPr id="3" name="Subtitle 2">
+            <a:extLst>
+              <a:ext uri="{FF2B5EF4-FFF2-40B4-BE49-F238E27FC236}">
+                <a16:creationId xmlns:a16="http://schemas.microsoft.com/office/drawing/2014/main" id="{255E737C-85F2-47BC-AD38-AD8B001473B7}"/>
+              </a:ext>
+            </a:extLst>
+          </p:cNvPr>
+          <p:cNvSpPr>
+            <a:spLocks noGrp="1"/>
+          </p:cNvSpPr>
+          <p:nvPr>
+            <p:ph type="subTitle" idx="1"/>
+          </p:nvPr>
+        </p:nvSpPr>
+        <p:spPr>
+          <a:xfrm>
+            <a:off x="1684867" y="1574800"/>
+            <a:ext cx="9694333" cy="4614333"/>
+          </a:xfrm>
+        </p:spPr>
+        <p:txBody>
+          <a:bodyPr>
+            <a:normAutofit/>
+          </a:bodyPr>
+          <a:lstStyle/>
+          <a:p>
+            <a:pPr marL="0" indent="0" algn="l">
+              <a:spcBef>
+                <a:spcPts val="0"/>
+              </a:spcBef>
+              <a:buNone/>
+            </a:pPr>
+            <a:r>
+              <a:rPr lang="en-US" sz="1400" b="1" i="0" dirty="0">
+                <a:latin typeface="Calibri" panose="020F0502020204030204" pitchFamily="34" charset="0"/>
+                <a:ea typeface="Calibri" panose="020F0502020204030204" pitchFamily="34" charset="0"/>
+                <a:cs typeface="Calibri" panose="020F0502020204030204" pitchFamily="34" charset="0"/>
+              </a:rPr>
+              <a:t>274 tests passing · 50 ms p99 budget verified under load to 100 req/s per instance · two concurrency defects found by our own harness and fixed · audit chain demonstrated under an actual tampering attempt.</a:t>
+            </a:r>
+          </a:p>
+          <a:p>
+            <a:pPr marL="0" indent="0" algn="l">
+              <a:spcBef>
+                <a:spcPts val="320"/>
+              </a:spcBef>
+              <a:buNone/>
+            </a:pPr>
+            <a:r>
+              <a:rPr lang="en-US" sz="1600" b="1" i="0" dirty="0">
+                <a:latin typeface="Calibri" panose="020F0502020204030204" pitchFamily="34" charset="0"/>
+                <a:ea typeface="Calibri" panose="020F0502020204030204" pitchFamily="34" charset="0"/>
+                <a:cs typeface="Calibri" panose="020F0502020204030204" pitchFamily="34" charset="0"/>
+              </a:rPr>
+              <a:t>Next, for Review-2</a:t>
+            </a:r>
+          </a:p>
+          <a:p>
+            <a:pPr marL="285750" indent="-285750" algn="l">
+              <a:spcBef>
+                <a:spcPts val="400"/>
+              </a:spcBef>
+              <a:buFont typeface="Arial" panose="020B0604020202020204" pitchFamily="34" charset="0"/>
+              <a:buChar char="•"/>
+            </a:pPr>
+            <a:r>
+              <a:rPr lang="en-US" sz="1350" b="0" i="0" dirty="0">
+                <a:latin typeface="Calibri" panose="020F0502020204030204" pitchFamily="34" charset="0"/>
+                <a:ea typeface="Calibri" panose="020F0502020204030204" pitchFamily="34" charset="0"/>
+                <a:cs typeface="Calibri" panose="020F0502020204030204" pitchFamily="34" charset="0"/>
+              </a:rPr>
+              <a:t>Admission control: shed load at the door rather than let a spike silently convert auto-approvals into review backlog.</a:t>
+            </a:r>
+          </a:p>
+          <a:p>
+            <a:pPr marL="285750" indent="-285750" algn="l">
+              <a:spcBef>
+                <a:spcPts val="400"/>
+              </a:spcBef>
+              <a:buFont typeface="Arial" panose="020B0604020202020204" pitchFamily="34" charset="0"/>
+              <a:buChar char="•"/>
+            </a:pPr>
+            <a:r>
+              <a:rPr lang="en-US" sz="1350" b="0" i="0" dirty="0">
+                <a:latin typeface="Calibri" panose="020F0502020204030204" pitchFamily="34" charset="0"/>
+                <a:ea typeface="Calibri" panose="020F0502020204030204" pitchFamily="34" charset="0"/>
+                <a:cs typeface="Calibri" panose="020F0502020204030204" pitchFamily="34" charset="0"/>
+              </a:rPr>
+              <a:t>Validate against real drift using the Lending Club dataset, replacing the controlled synthetic scenarios.</a:t>
+            </a:r>
+          </a:p>
+          <a:p>
+            <a:pPr marL="285750" indent="-285750" algn="l">
+              <a:spcBef>
+                <a:spcPts val="400"/>
+              </a:spcBef>
+              <a:buFont typeface="Arial" panose="020B0604020202020204" pitchFamily="34" charset="0"/>
+              <a:buChar char="•"/>
+            </a:pPr>
+            <a:r>
+              <a:rPr lang="en-US" sz="1350" b="0" i="0" dirty="0">
+                <a:latin typeface="Calibri" panose="020F0502020204030204" pitchFamily="34" charset="0"/>
+                <a:ea typeface="Calibri" panose="020F0502020204030204" pitchFamily="34" charset="0"/>
+                <a:cs typeface="Calibri" panose="020F0502020204030204" pitchFamily="34" charset="0"/>
+              </a:rPr>
+              <a:t>Model and data versioning, plus a retraining trigger — the components practitioners named as prerequisites.</a:t>
+            </a:r>
+          </a:p>
+          <a:p>
+            <a:pPr marL="285750" indent="-285750" algn="l">
+              <a:spcBef>
+                <a:spcPts val="400"/>
+              </a:spcBef>
+              <a:buFont typeface="Arial" panose="020B0604020202020204" pitchFamily="34" charset="0"/>
+              <a:buChar char="•"/>
+            </a:pPr>
+            <a:r>
+              <a:rPr lang="en-US" sz="1350" b="0" i="0" dirty="0">
+                <a:latin typeface="Calibri" panose="020F0502020204030204" pitchFamily="34" charset="0"/>
+                <a:ea typeface="Calibri" panose="020F0502020204030204" pitchFamily="34" charset="0"/>
+                <a:cs typeface="Calibri" panose="020F0502020204030204" pitchFamily="34" charset="0"/>
+              </a:rPr>
+              <a:t>Move the audit write off the hot path, and re-measure against Postgres rather than SQLite.</a:t>
+            </a:r>
+          </a:p>
+        </p:txBody>
+      </p:sp>
+      <p:pic>
+        <p:nvPicPr>
+          <p:cNvPr id="5" name="Graphic 4">
+            <a:extLst>
+              <a:ext uri="{FF2B5EF4-FFF2-40B4-BE49-F238E27FC236}">
+                <a16:creationId xmlns:a16="http://schemas.microsoft.com/office/drawing/2014/main" id="{E7125167-8301-4D88-B79A-A8DA3C19E0D6}"/>
+              </a:ext>
+            </a:extLst>
+          </p:cNvPr>
+          <p:cNvPicPr>
+            <a:picLocks noChangeAspect="1"/>
+          </p:cNvPicPr>
+          <p:nvPr/>
+        </p:nvPicPr>
+        <p:blipFill>
+          <a:blip r:embed="rId2">
+            <a:extLst>
+              <a:ext uri="{96DAC541-7B7A-43D3-8B79-37D633B846F1}">
+                <asvg:svgBlip xmlns:asvg="http://schemas.microsoft.com/office/drawing/2016/SVG/main" r:embed="rId3"/>
+              </a:ext>
+            </a:extLst>
+          </a:blip>
+          <a:stretch>
+            <a:fillRect/>
+          </a:stretch>
+        </p:blipFill>
+        <p:spPr>
+          <a:xfrm>
+            <a:off x="127001" y="86782"/>
+            <a:ext cx="1159932" cy="1159932"/>
+          </a:xfrm>
+          <a:prstGeom prst="rect">
+            <a:avLst/>
+          </a:prstGeom>
+        </p:spPr>
+      </p:pic>
+      <p:sp>
+        <p:nvSpPr>
+          <p:cNvPr id="4" name="Date Placeholder 3">
+            <a:extLst>
+              <a:ext uri="{FF2B5EF4-FFF2-40B4-BE49-F238E27FC236}">
+                <a16:creationId xmlns:a16="http://schemas.microsoft.com/office/drawing/2014/main" id="{35032362-C5A5-4DBF-AD79-DE6FB7439999}"/>
+              </a:ext>
+            </a:extLst>
+          </p:cNvPr>
+          <p:cNvSpPr>
+            <a:spLocks noGrp="1"/>
+          </p:cNvSpPr>
+          <p:nvPr>
+            <p:ph type="dt" sz="half" idx="10"/>
+          </p:nvPr>
+        </p:nvSpPr>
+        <p:spPr/>
+        <p:txBody>
+          <a:bodyPr/>
+          <a:lstStyle/>
+          <a:p>
+            <a:fld id="{64C96E34-94C0-49E4-A53B-4A44141FD3C8}" type="datetime3">
+              <a:rPr lang="en-US" smtClean="0"/>
+              <a:t>12 September 2026</a:t>
+            </a:fld>
+            <a:endParaRPr lang="en-US" dirty="0"/>
+          </a:p>
+        </p:txBody>
+      </p:sp>
+      <p:sp>
+        <p:nvSpPr>
+          <p:cNvPr id="6" name="Slide Number Placeholder 5">
+            <a:extLst>
+              <a:ext uri="{FF2B5EF4-FFF2-40B4-BE49-F238E27FC236}">
+                <a16:creationId xmlns:a16="http://schemas.microsoft.com/office/drawing/2014/main" id="{115AAB64-5B51-4B5A-B69E-D96362CE6E74}"/>
+              </a:ext>
+            </a:extLst>
+          </p:cNvPr>
+          <p:cNvSpPr>
+            <a:spLocks noGrp="1"/>
+          </p:cNvSpPr>
+          <p:nvPr>
+            <p:ph type="sldNum" sz="quarter" idx="12"/>
+          </p:nvPr>
+        </p:nvSpPr>
+        <p:spPr/>
+        <p:txBody>
+          <a:bodyPr/>
+          <a:lstStyle/>
+          <a:p>
+            <a:fld id="{D57F1E4F-1CFF-5643-939E-217C01CDF565}" type="slidenum">
+              <a:rPr lang="en-US" smtClean="0"/>
+              <a:pPr/>
+              <a:t>9</a:t>
+            </a:fld>
+            <a:endParaRPr lang="en-US" dirty="0"/>
+          </a:p>
+        </p:txBody>
+      </p:sp>
+      <p:sp>
+        <p:nvSpPr>
+          <p:cNvPr id="7" name="Footer Placeholder 6">
+            <a:extLst>
+              <a:ext uri="{FF2B5EF4-FFF2-40B4-BE49-F238E27FC236}">
+                <a16:creationId xmlns:a16="http://schemas.microsoft.com/office/drawing/2014/main" id="{8683C6DF-27D9-468B-A1AB-FE568488FE57}"/>
+              </a:ext>
+            </a:extLst>
+          </p:cNvPr>
+          <p:cNvSpPr>
+            <a:spLocks noGrp="1"/>
+          </p:cNvSpPr>
+          <p:nvPr>
+            <p:ph type="ftr" sz="quarter" idx="11"/>
+          </p:nvPr>
+        </p:nvSpPr>
+        <p:spPr/>
+        <p:txBody>
+          <a:bodyPr/>
+          <a:lstStyle/>
+          <a:p>
+            <a:r>
+              <a:rPr lang="en-US"/>
+              <a:t>Dept of AI &amp; DS</a:t>
+            </a:r>
+            <a:endParaRPr lang="en-US" dirty="0"/>
+          </a:p>
+        </p:txBody>
+      </p:sp>
+      <p:graphicFrame>
+        <p:nvGraphicFramePr>
+          <p:cNvPr id="8" name="Table 7"/>
+          <p:cNvGraphicFramePr>
+            <a:graphicFrameLocks noGrp="1"/>
+          </p:cNvGraphicFramePr>
+          <p:nvPr/>
+        </p:nvGraphicFramePr>
+        <p:xfrm>
+          <a:off x="960120" y="4343400"/>
+          <a:ext cx="10241279" cy="101600"/>
+        </p:xfrm>
+        <a:graphic>
+          <a:graphicData uri="http://schemas.openxmlformats.org/drawingml/2006/table">
+            <a:tbl>
+              <a:tblPr firstRow="1">
+                <a:tableStyleId>{5C22544A-7EE6-4342-B048-85BDC9FD1C3A}</a:tableStyleId>
+              </a:tblPr>
+              <a:tblGrid>
+                <a:gridCol w="2048256"/>
+                <a:gridCol w="1433779"/>
+                <a:gridCol w="6759244"/>
+              </a:tblGrid>
+              <a:tr h="25400">
+                <a:tc>
+                  <a:txBody>
+                    <a:bodyPr wrap="square"/>
+                    <a:lstStyle/>
+                    <a:p>
+                      <a:r>
+                        <a:rPr sz="1100" b="1">
+                          <a:solidFill>
+                            <a:srgbClr val="FFFFFF"/>
+                          </a:solidFill>
+                          <a:latin typeface="Calibri"/>
+                        </a:rPr>
+                        <a:t>Team member</a:t>
+                      </a:r>
+                    </a:p>
+                  </a:txBody>
+                  <a:tcPr marL="63500" marR="63500" marT="38100" marB="38100">
+                    <a:solidFill>
+                      <a:srgbClr val="1F5CA8"/>
+                    </a:solidFill>
+                  </a:tcPr>
+                </a:tc>
+                <a:tc>
+                  <a:txBody>
+                    <a:bodyPr wrap="square"/>
+                    <a:lstStyle/>
+                    <a:p>
+                      <a:r>
+                        <a:rPr sz="1100" b="1">
+                          <a:solidFill>
+                            <a:srgbClr val="FFFFFF"/>
+                          </a:solidFill>
+                          <a:latin typeface="Calibri"/>
+                        </a:rPr>
+                        <a:t>USN</a:t>
+                      </a:r>
+                    </a:p>
+                  </a:txBody>
+                  <a:tcPr marL="63500" marR="63500" marT="38100" marB="38100">
+                    <a:solidFill>
+                      <a:srgbClr val="1F5CA8"/>
+                    </a:solidFill>
+                  </a:tcPr>
+                </a:tc>
+                <a:tc>
+                  <a:txBody>
+                    <a:bodyPr wrap="square"/>
+                    <a:lstStyle/>
+                    <a:p>
+                      <a:r>
+                        <a:rPr sz="1100" b="1">
+                          <a:solidFill>
+                            <a:srgbClr val="FFFFFF"/>
+                          </a:solidFill>
+                          <a:latin typeface="Calibri"/>
+                        </a:rPr>
+                        <a:t>Modules owned</a:t>
+                      </a:r>
+                    </a:p>
+                  </a:txBody>
+                  <a:tcPr marL="63500" marR="63500" marT="38100" marB="38100">
+                    <a:solidFill>
+                      <a:srgbClr val="1F5CA8"/>
+                    </a:solidFill>
+                  </a:tcPr>
+                </a:tc>
+              </a:tr>
+              <a:tr h="25400">
+                <a:tc>
+                  <a:txBody>
+                    <a:bodyPr wrap="square"/>
+                    <a:lstStyle/>
+                    <a:p>
+                      <a:r>
+                        <a:rPr sz="1100" b="0">
+                          <a:latin typeface="Calibri"/>
+                        </a:rPr>
+                        <a:t>AYUSH PANDEY</a:t>
+                      </a:r>
+                    </a:p>
+                  </a:txBody>
+                  <a:tcPr marL="63500" marR="63500" marT="38100" marB="38100">
+                    <a:noFill/>
+                  </a:tcPr>
+                </a:tc>
+                <a:tc>
+                  <a:txBody>
+                    <a:bodyPr wrap="square"/>
+                    <a:lstStyle/>
+                    <a:p>
+                      <a:r>
+                        <a:rPr sz="1100" b="0">
+                          <a:latin typeface="Calibri"/>
+                        </a:rPr>
+                        <a:t>1BM23AD074</a:t>
+                      </a:r>
+                    </a:p>
+                  </a:txBody>
+                  <a:tcPr marL="63500" marR="63500" marT="38100" marB="38100">
+                    <a:noFill/>
+                  </a:tcPr>
+                </a:tc>
+                <a:tc>
+                  <a:txBody>
+                    <a:bodyPr wrap="square"/>
+                    <a:lstStyle/>
+                    <a:p>
+                      <a:r>
+                        <a:rPr sz="1100" b="0">
+                          <a:latin typeface="Calibri"/>
+                        </a:rPr>
+                        <a:t>Architecture and ADRs · drift engine (PSI/KS detectors, severity roll-up, offline worker) · trust engine fusion and decision matrix</a:t>
+                      </a:r>
+                    </a:p>
+                  </a:txBody>
+                  <a:tcPr marL="63500" marR="63500" marT="38100" marB="38100">
+                    <a:noFill/>
+                  </a:tcPr>
+                </a:tc>
+              </a:tr>
+              <a:tr h="25400">
+                <a:tc>
+                  <a:txBody>
+                    <a:bodyPr wrap="square"/>
+                    <a:lstStyle/>
+                    <a:p>
+                      <a:r>
+                        <a:rPr sz="1100" b="0">
+                          <a:latin typeface="Calibri"/>
+                        </a:rPr>
+                        <a:t>VIVEK BOORA</a:t>
+                      </a:r>
+                    </a:p>
+                  </a:txBody>
+                  <a:tcPr marL="63500" marR="63500" marT="38100" marB="38100">
+                    <a:solidFill>
+                      <a:srgbClr val="F4F6F9"/>
+                    </a:solidFill>
+                  </a:tcPr>
+                </a:tc>
+                <a:tc>
+                  <a:txBody>
+                    <a:bodyPr wrap="square"/>
+                    <a:lstStyle/>
+                    <a:p>
+                      <a:r>
+                        <a:rPr sz="1100" b="0">
+                          <a:latin typeface="Calibri"/>
+                        </a:rPr>
+                        <a:t>1BM23AD073</a:t>
+                      </a:r>
+                    </a:p>
+                  </a:txBody>
+                  <a:tcPr marL="63500" marR="63500" marT="38100" marB="38100">
+                    <a:solidFill>
+                      <a:srgbClr val="F4F6F9"/>
+                    </a:solidFill>
+                  </a:tcPr>
+                </a:tc>
+                <a:tc>
+                  <a:txBody>
+                    <a:bodyPr wrap="square"/>
+                    <a:lstStyle/>
+                    <a:p>
+                      <a:r>
+                        <a:rPr sz="1100" b="0">
+                          <a:latin typeface="Calibri"/>
+                        </a:rPr>
+                        <a:t>Gateway and control-plane APIs · policy engine and rule grammar · tamper-evident audit chain and evidence export</a:t>
+                      </a:r>
+                    </a:p>
+                  </a:txBody>
+                  <a:tcPr marL="63500" marR="63500" marT="38100" marB="38100">
+                    <a:solidFill>
+                      <a:srgbClr val="F4F6F9"/>
+                    </a:solidFill>
+                  </a:tcPr>
+                </a:tc>
+              </a:tr>
+              <a:tr h="25400">
+                <a:tc>
+                  <a:txBody>
+                    <a:bodyPr wrap="square"/>
+                    <a:lstStyle/>
+                    <a:p>
+                      <a:r>
+                        <a:rPr sz="1100" b="0">
+                          <a:latin typeface="Calibri"/>
+                        </a:rPr>
+                        <a:t>NITIN</a:t>
+                      </a:r>
+                    </a:p>
+                  </a:txBody>
+                  <a:tcPr marL="63500" marR="63500" marT="38100" marB="38100">
+                    <a:noFill/>
+                  </a:tcPr>
+                </a:tc>
+                <a:tc>
+                  <a:txBody>
+                    <a:bodyPr wrap="square"/>
+                    <a:lstStyle/>
+                    <a:p>
+                      <a:r>
+                        <a:rPr sz="1100" b="0">
+                          <a:latin typeface="Calibri"/>
+                        </a:rPr>
+                        <a:t>1BM24AD404</a:t>
+                      </a:r>
+                    </a:p>
+                  </a:txBody>
+                  <a:tcPr marL="63500" marR="63500" marT="38100" marB="38100">
+                    <a:noFill/>
+                  </a:tcPr>
+                </a:tc>
+                <a:tc>
+                  <a:txBody>
+                    <a:bodyPr wrap="square"/>
+                    <a:lstStyle/>
+                    <a:p>
+                      <a:r>
+                        <a:rPr sz="1100" b="0">
+                          <a:latin typeface="Calibri"/>
+                        </a:rPr>
+                        <a:t>Python SDK · React operator dashboard · fintech demonstration · 268-test suite across unit, integration and end-to-end</a:t>
+                      </a:r>
+                    </a:p>
+                  </a:txBody>
+                  <a:tcPr marL="63500" marR="63500" marT="38100" marB="38100">
+                    <a:noFill/>
+                  </a:tcPr>
+                </a:tc>
+              </a:tr>
+            </a:tbl>
+          </a:graphicData>
+        </a:graphic>
+      </p:graphicFrame>
+    </p:spTree>
+    <p:extLst>
+      <p:ext uri="{BB962C8B-B14F-4D97-AF65-F5344CB8AC3E}">
+        <p14:creationId xmlns:p14="http://schemas.microsoft.com/office/powerpoint/2010/main" val="68599917"/>
       </p:ext>
     </p:extLst>
   </p:cSld>
@@ -7582,7 +10206,7 @@
           <a:p>
             <a:fld id="{64C96E34-94C0-49E4-A53B-4A44141FD3C8}" type="datetime3">
               <a:rPr lang="en-US" smtClean="0"/>
-              <a:t>4 September 2026</a:t>
+              <a:t>12 September 2026</a:t>
             </a:fld>
             <a:endParaRPr lang="en-US" dirty="0"/>
           </a:p>
@@ -7850,7 +10474,7 @@
           <a:p>
             <a:fld id="{64C96E34-94C0-49E4-A53B-4A44141FD3C8}" type="datetime3">
               <a:rPr lang="en-US" smtClean="0"/>
-              <a:t>4 September 2026</a:t>
+              <a:t>12 September 2026</a:t>
             </a:fld>
             <a:endParaRPr lang="en-US" dirty="0"/>
           </a:p>
@@ -8118,7 +10742,7 @@
           <a:p>
             <a:fld id="{64C96E34-94C0-49E4-A53B-4A44141FD3C8}" type="datetime3">
               <a:rPr lang="en-US" smtClean="0"/>
-              <a:t>4 September 2026</a:t>
+              <a:t>12 September 2026</a:t>
             </a:fld>
             <a:endParaRPr lang="en-US" dirty="0"/>
           </a:p>
@@ -9191,7 +11815,7 @@
           <a:p>
             <a:fld id="{64C96E34-94C0-49E4-A53B-4A44141FD3C8}" type="datetime3">
               <a:rPr lang="en-US" smtClean="0"/>
-              <a:t>4 September 2026</a:t>
+              <a:t>12 September 2026</a:t>
             </a:fld>
             <a:endParaRPr lang="en-US" dirty="0"/>
           </a:p>
@@ -9600,7 +12224,7 @@
           <a:p>
             <a:fld id="{64C96E34-94C0-49E4-A53B-4A44141FD3C8}" type="datetime3">
               <a:rPr lang="en-US" smtClean="0"/>
-              <a:t>4 September 2026</a:t>
+              <a:t>12 September 2026</a:t>
             </a:fld>
             <a:endParaRPr lang="en-US" dirty="0"/>
           </a:p>
@@ -9844,7 +12468,7 @@
           <a:p>
             <a:fld id="{64C96E34-94C0-49E4-A53B-4A44141FD3C8}" type="datetime3">
               <a:rPr lang="en-US" smtClean="0"/>
-              <a:t>4 September 2026</a:t>
+              <a:t>12 September 2026</a:t>
             </a:fld>
             <a:endParaRPr lang="en-US" dirty="0"/>
           </a:p>
@@ -10946,7 +13570,7 @@
           <a:p>
             <a:fld id="{64C96E34-94C0-49E4-A53B-4A44141FD3C8}" type="datetime3">
               <a:rPr lang="en-US" smtClean="0"/>
-              <a:t>4 September 2026</a:t>
+              <a:t>12 September 2026</a:t>
             </a:fld>
             <a:endParaRPr lang="en-US" dirty="0"/>
           </a:p>

</xml_diff>